<commit_message>
Add strategy slides and assemble the Regulift pitch deck
- regulift-deck.pptx / .pdf: 11-slide deck, Simone's Canva slides plus
  five generated slides (gate table, Germany is the goal, Netherlands
  first, business model, founders); packages slide dropped
- pitch/src/strategy.js: pptxgenjs generator for the five slides in
  Simone's style (Poppins, nav positions, colours)
- pitch/src/assemble.py: splices generated slides into the Canva export,
  copies nav bar and page pill, renumbers pages
- pitch/src/build-deck.sh: one-command rebuild, validate and render
- pitch/src/assets: Simone's deck export, Netherlands map, founder photos
- pitch/export: 4000px PNGs of the new slides for Canva
- market.js / regulift-central.pptx: gate-table legend and renamed columns
- HANDOFF-strategy.md sections 10-12 and src/README: decisions, pipeline,
  open price questions
- .gitignore: LibreOffice lock files
</commit_message>
<xml_diff>
--- a/fable-andi/pitch/market-slides.pptx
+++ b/fable-andi/pitch/market-slides.pptx
@@ -1366,14 +1366,41 @@
       </p:sp>
       <p:sp>
         <p:nvSpPr>
-          <p:cNvPr id="12" name="Text 9"/>
+          <p:cNvPr id="12" name="Shape 9"/>
+          <p:cNvSpPr/>
+          <p:nvPr/>
+        </p:nvSpPr>
+        <p:spPr>
+          <a:xfrm>
+            <a:off x="11475720" y="1517904"/>
+            <a:ext cx="502920" cy="201168"/>
+          </a:xfrm>
+          <a:prstGeom prst="roundRect">
+            <a:avLst>
+              <a:gd name="adj" fmla="val 22727"/>
+            </a:avLst>
+          </a:prstGeom>
+          <a:solidFill>
+            <a:srgbClr val="FCFBF8"/>
+          </a:solidFill>
+          <a:ln w="9525">
+            <a:solidFill>
+              <a:srgbClr val="E3E0D7"/>
+            </a:solidFill>
+            <a:prstDash val="solid"/>
+          </a:ln>
+        </p:spPr>
+      </p:sp>
+      <p:sp>
+        <p:nvSpPr>
+          <p:cNvPr id="13" name="Text 10"/>
           <p:cNvSpPr txBox="1"/>
           <p:nvPr/>
         </p:nvSpPr>
         <p:spPr>
           <a:xfrm>
-            <a:off x="1417320" y="2926080"/>
-            <a:ext cx="2743200" cy="320040"/>
+            <a:off x="12161520" y="1481328"/>
+            <a:ext cx="4983480" cy="457200"/>
           </a:xfrm>
           <a:prstGeom prst="rect">
             <a:avLst/>
@@ -1389,7 +1416,7 @@
               <a:buNone/>
             </a:pPr>
             <a:r>
-              <a:rPr lang="en-US" sz="1400" dirty="0">
+              <a:rPr lang="en-US" sz="1200" dirty="0">
                 <a:solidFill>
                   <a:srgbClr val="1C2B2F"/>
                 </a:solidFill>
@@ -1397,22 +1424,138 @@
                 <a:ea typeface="Geist Medium" pitchFamily="34" charset="-122"/>
                 <a:cs typeface="Geist Medium" pitchFamily="34" charset="-120"/>
               </a:rPr>
-              <a:t>Country</a:t>
-            </a:r>
-            <a:endParaRPr lang="en-US" sz="1400" dirty="0"/>
+              <a:t>Grey rows </a:t>
+            </a:r>
+            <a:pPr indent="0" marL="0">
+              <a:buNone/>
+            </a:pPr>
+            <a:r>
+              <a:rPr lang="en-US" sz="1200" dirty="0">
+                <a:solidFill>
+                  <a:srgbClr val="55676B"/>
+                </a:solidFill>
+                <a:latin typeface="Geist" pitchFamily="34" charset="0"/>
+                <a:ea typeface="Geist" pitchFamily="34" charset="-122"/>
+                <a:cs typeface="Geist" pitchFamily="34" charset="-120"/>
+              </a:rPr>
+              <a:t>fail the gate.</a:t>
+            </a:r>
+            <a:endParaRPr lang="en-US" sz="1200" dirty="0"/>
           </a:p>
         </p:txBody>
       </p:sp>
       <p:sp>
         <p:nvSpPr>
-          <p:cNvPr id="13" name="Text 10"/>
+          <p:cNvPr id="14" name="Shape 11"/>
+          <p:cNvSpPr/>
+          <p:nvPr/>
+        </p:nvSpPr>
+        <p:spPr>
+          <a:xfrm>
+            <a:off x="11567160" y="1572768"/>
+            <a:ext cx="91440" cy="91440"/>
+          </a:xfrm>
+          <a:prstGeom prst="ellipse">
+            <a:avLst/>
+          </a:prstGeom>
+          <a:solidFill>
+            <a:srgbClr val="8A9A9D"/>
+          </a:solidFill>
+          <a:ln w="12700">
+            <a:solidFill>
+              <a:srgbClr val="8A9A9D"/>
+            </a:solidFill>
+            <a:prstDash val="solid"/>
+          </a:ln>
+        </p:spPr>
+      </p:sp>
+      <p:sp>
+        <p:nvSpPr>
+          <p:cNvPr id="15" name="Shape 12"/>
+          <p:cNvSpPr/>
+          <p:nvPr/>
+        </p:nvSpPr>
+        <p:spPr>
+          <a:xfrm>
+            <a:off x="11686032" y="1572768"/>
+            <a:ext cx="91440" cy="91440"/>
+          </a:xfrm>
+          <a:prstGeom prst="ellipse">
+            <a:avLst/>
+          </a:prstGeom>
+          <a:solidFill>
+            <a:srgbClr val="8A9A9D"/>
+          </a:solidFill>
+          <a:ln w="12700">
+            <a:solidFill>
+              <a:srgbClr val="8A9A9D"/>
+            </a:solidFill>
+            <a:prstDash val="solid"/>
+          </a:ln>
+        </p:spPr>
+      </p:sp>
+      <p:sp>
+        <p:nvSpPr>
+          <p:cNvPr id="16" name="Shape 13"/>
+          <p:cNvSpPr/>
+          <p:nvPr/>
+        </p:nvSpPr>
+        <p:spPr>
+          <a:xfrm>
+            <a:off x="11804904" y="1572768"/>
+            <a:ext cx="91440" cy="91440"/>
+          </a:xfrm>
+          <a:prstGeom prst="ellipse">
+            <a:avLst/>
+          </a:prstGeom>
+          <a:solidFill>
+            <a:srgbClr val="E3E0D7"/>
+          </a:solidFill>
+          <a:ln w="12700">
+            <a:solidFill>
+              <a:srgbClr val="E3E0D7"/>
+            </a:solidFill>
+            <a:prstDash val="solid"/>
+          </a:ln>
+        </p:spPr>
+      </p:sp>
+      <p:sp>
+        <p:nvSpPr>
+          <p:cNvPr id="17" name="Shape 14"/>
+          <p:cNvSpPr/>
+          <p:nvPr/>
+        </p:nvSpPr>
+        <p:spPr>
+          <a:xfrm>
+            <a:off x="11475720" y="2020824"/>
+            <a:ext cx="502920" cy="201168"/>
+          </a:xfrm>
+          <a:prstGeom prst="roundRect">
+            <a:avLst>
+              <a:gd name="adj" fmla="val 22727"/>
+            </a:avLst>
+          </a:prstGeom>
+          <a:solidFill>
+            <a:srgbClr val="FCFBF8"/>
+          </a:solidFill>
+          <a:ln w="9525">
+            <a:solidFill>
+              <a:srgbClr val="E3E0D7"/>
+            </a:solidFill>
+            <a:prstDash val="solid"/>
+          </a:ln>
+        </p:spPr>
+      </p:sp>
+      <p:sp>
+        <p:nvSpPr>
+          <p:cNvPr id="18" name="Text 15"/>
           <p:cNvSpPr txBox="1"/>
           <p:nvPr/>
         </p:nvSpPr>
         <p:spPr>
           <a:xfrm>
-            <a:off x="4434840" y="2926080"/>
-            <a:ext cx="2377440" cy="320040"/>
+            <a:off x="12161520" y="1984248"/>
+            <a:ext cx="4983480" cy="457200"/>
           </a:xfrm>
           <a:prstGeom prst="rect">
             <a:avLst/>
@@ -1428,7 +1571,7 @@
               <a:buNone/>
             </a:pPr>
             <a:r>
-              <a:rPr lang="en-US" sz="1400" dirty="0">
+              <a:rPr lang="en-US" sz="1200" dirty="0">
                 <a:solidFill>
                   <a:srgbClr val="1C2B2F"/>
                 </a:solidFill>
@@ -1436,29 +1579,196 @@
                 <a:ea typeface="Geist Medium" pitchFamily="34" charset="-122"/>
                 <a:cs typeface="Geist Medium" pitchFamily="34" charset="-120"/>
               </a:rPr>
-              <a:t>Adviser legal </a:t>
-            </a:r>
-            <a:pPr indent="0" marL="0">
-              <a:buNone/>
-            </a:pPr>
-            <a:r>
-              <a:rPr lang="en-US" sz="1400" baseline="30000" dirty="0">
+              <a:t>Black rows </a:t>
+            </a:r>
+            <a:pPr indent="0" marL="0">
+              <a:buNone/>
+            </a:pPr>
+            <a:r>
+              <a:rPr lang="en-US" sz="1200" dirty="0">
                 <a:solidFill>
                   <a:srgbClr val="55676B"/>
+                </a:solidFill>
+                <a:latin typeface="Geist" pitchFamily="34" charset="0"/>
+                <a:ea typeface="Geist" pitchFamily="34" charset="-122"/>
+                <a:cs typeface="Geist" pitchFamily="34" charset="-120"/>
+              </a:rPr>
+              <a:t>pass the gate.</a:t>
+            </a:r>
+            <a:endParaRPr lang="en-US" sz="1200" dirty="0"/>
+          </a:p>
+        </p:txBody>
+      </p:sp>
+      <p:sp>
+        <p:nvSpPr>
+          <p:cNvPr id="19" name="Shape 16"/>
+          <p:cNvSpPr/>
+          <p:nvPr/>
+        </p:nvSpPr>
+        <p:spPr>
+          <a:xfrm>
+            <a:off x="11567160" y="2075688"/>
+            <a:ext cx="91440" cy="91440"/>
+          </a:xfrm>
+          <a:prstGeom prst="ellipse">
+            <a:avLst/>
+          </a:prstGeom>
+          <a:solidFill>
+            <a:srgbClr val="1C2B2F"/>
+          </a:solidFill>
+          <a:ln w="12700">
+            <a:solidFill>
+              <a:srgbClr val="1C2B2F"/>
+            </a:solidFill>
+            <a:prstDash val="solid"/>
+          </a:ln>
+        </p:spPr>
+      </p:sp>
+      <p:sp>
+        <p:nvSpPr>
+          <p:cNvPr id="20" name="Shape 17"/>
+          <p:cNvSpPr/>
+          <p:nvPr/>
+        </p:nvSpPr>
+        <p:spPr>
+          <a:xfrm>
+            <a:off x="11686032" y="2075688"/>
+            <a:ext cx="91440" cy="91440"/>
+          </a:xfrm>
+          <a:prstGeom prst="ellipse">
+            <a:avLst/>
+          </a:prstGeom>
+          <a:solidFill>
+            <a:srgbClr val="1C2B2F"/>
+          </a:solidFill>
+          <a:ln w="12700">
+            <a:solidFill>
+              <a:srgbClr val="1C2B2F"/>
+            </a:solidFill>
+            <a:prstDash val="solid"/>
+          </a:ln>
+        </p:spPr>
+      </p:sp>
+      <p:sp>
+        <p:nvSpPr>
+          <p:cNvPr id="21" name="Shape 18"/>
+          <p:cNvSpPr/>
+          <p:nvPr/>
+        </p:nvSpPr>
+        <p:spPr>
+          <a:xfrm>
+            <a:off x="11804904" y="2075688"/>
+            <a:ext cx="91440" cy="91440"/>
+          </a:xfrm>
+          <a:prstGeom prst="ellipse">
+            <a:avLst/>
+          </a:prstGeom>
+          <a:solidFill>
+            <a:srgbClr val="1C2B2F"/>
+          </a:solidFill>
+          <a:ln w="12700">
+            <a:solidFill>
+              <a:srgbClr val="1C2B2F"/>
+            </a:solidFill>
+            <a:prstDash val="solid"/>
+          </a:ln>
+        </p:spPr>
+      </p:sp>
+      <p:sp>
+        <p:nvSpPr>
+          <p:cNvPr id="22" name="Text 19"/>
+          <p:cNvSpPr txBox="1"/>
+          <p:nvPr/>
+        </p:nvSpPr>
+        <p:spPr>
+          <a:xfrm>
+            <a:off x="1417320" y="2926080"/>
+            <a:ext cx="2743200" cy="320040"/>
+          </a:xfrm>
+          <a:prstGeom prst="rect">
+            <a:avLst/>
+          </a:prstGeom>
+          <a:noFill/>
+          <a:ln/>
+        </p:spPr>
+        <p:txBody>
+          <a:bodyPr wrap="square" lIns="0" tIns="0" rIns="0" bIns="0" rtlCol="0" anchor="t"/>
+          <a:lstStyle/>
+          <a:p>
+            <a:pPr indent="0" marL="0">
+              <a:buNone/>
+            </a:pPr>
+            <a:r>
+              <a:rPr lang="en-US" sz="1300" dirty="0">
+                <a:solidFill>
+                  <a:srgbClr val="1C2B2F"/>
                 </a:solidFill>
                 <a:latin typeface="Geist Medium" pitchFamily="34" charset="0"/>
                 <a:ea typeface="Geist Medium" pitchFamily="34" charset="-122"/>
                 <a:cs typeface="Geist Medium" pitchFamily="34" charset="-120"/>
               </a:rPr>
+              <a:t>Country</a:t>
+            </a:r>
+            <a:endParaRPr lang="en-US" sz="1300" dirty="0"/>
+          </a:p>
+        </p:txBody>
+      </p:sp>
+      <p:sp>
+        <p:nvSpPr>
+          <p:cNvPr id="23" name="Text 20"/>
+          <p:cNvSpPr txBox="1"/>
+          <p:nvPr/>
+        </p:nvSpPr>
+        <p:spPr>
+          <a:xfrm>
+            <a:off x="4434840" y="2926080"/>
+            <a:ext cx="2514600" cy="320040"/>
+          </a:xfrm>
+          <a:prstGeom prst="rect">
+            <a:avLst/>
+          </a:prstGeom>
+          <a:noFill/>
+          <a:ln/>
+        </p:spPr>
+        <p:txBody>
+          <a:bodyPr wrap="none" lIns="0" tIns="0" rIns="0" bIns="0" rtlCol="0" anchor="t"/>
+          <a:lstStyle/>
+          <a:p>
+            <a:pPr indent="0" marL="0">
+              <a:buNone/>
+            </a:pPr>
+            <a:r>
+              <a:rPr lang="en-US" sz="1300" dirty="0">
+                <a:solidFill>
+                  <a:srgbClr val="1C2B2F"/>
+                </a:solidFill>
+                <a:latin typeface="Geist Medium" pitchFamily="34" charset="0"/>
+                <a:ea typeface="Geist Medium" pitchFamily="34" charset="-122"/>
+                <a:cs typeface="Geist Medium" pitchFamily="34" charset="-120"/>
+              </a:rPr>
+              <a:t>AI may advise </a:t>
+            </a:r>
+            <a:pPr indent="0" marL="0">
+              <a:buNone/>
+            </a:pPr>
+            <a:r>
+              <a:rPr lang="en-US" sz="1300" baseline="30000" dirty="0">
+                <a:solidFill>
+                  <a:srgbClr val="55676B"/>
+                </a:solidFill>
+                <a:latin typeface="Geist Medium" pitchFamily="34" charset="0"/>
+                <a:ea typeface="Geist Medium" pitchFamily="34" charset="-122"/>
+                <a:cs typeface="Geist Medium" pitchFamily="34" charset="-120"/>
+              </a:rPr>
               <a:t>1</a:t>
             </a:r>
-            <a:endParaRPr lang="en-US" sz="1400" dirty="0"/>
+            <a:endParaRPr lang="en-US" sz="1300" dirty="0"/>
           </a:p>
         </p:txBody>
       </p:sp>
       <p:sp>
         <p:nvSpPr>
-          <p:cNvPr id="14" name="Text 11"/>
+          <p:cNvPr id="24" name="Text 21"/>
           <p:cNvSpPr txBox="1"/>
           <p:nvPr/>
         </p:nvSpPr>
@@ -1489,7 +1799,7 @@
                 <a:ea typeface="Geist" pitchFamily="34" charset="-122"/>
                 <a:cs typeface="Geist" pitchFamily="34" charset="-120"/>
               </a:rPr>
-              <a:t>software answers directly</a:t>
+              <a:t>legal without a lawyer signing</a:t>
             </a:r>
             <a:endParaRPr lang="en-US" sz="1150" dirty="0"/>
           </a:p>
@@ -1497,14 +1807,67 @@
       </p:sp>
       <p:sp>
         <p:nvSpPr>
-          <p:cNvPr id="15" name="Text 12"/>
+          <p:cNvPr id="25" name="Text 22"/>
           <p:cNvSpPr txBox="1"/>
           <p:nvPr/>
         </p:nvSpPr>
         <p:spPr>
           <a:xfrm>
             <a:off x="6995160" y="2926080"/>
-            <a:ext cx="2377440" cy="320040"/>
+            <a:ext cx="2514600" cy="320040"/>
+          </a:xfrm>
+          <a:prstGeom prst="rect">
+            <a:avLst/>
+          </a:prstGeom>
+          <a:noFill/>
+          <a:ln/>
+        </p:spPr>
+        <p:txBody>
+          <a:bodyPr wrap="none" lIns="0" tIns="0" rIns="0" bIns="0" rtlCol="0" anchor="t"/>
+          <a:lstStyle/>
+          <a:p>
+            <a:pPr indent="0" marL="0">
+              <a:buNone/>
+            </a:pPr>
+            <a:r>
+              <a:rPr lang="en-US" sz="1300" dirty="0">
+                <a:solidFill>
+                  <a:srgbClr val="1C2B2F"/>
+                </a:solidFill>
+                <a:latin typeface="Geist Medium" pitchFamily="34" charset="0"/>
+                <a:ea typeface="Geist Medium" pitchFamily="34" charset="-122"/>
+                <a:cs typeface="Geist Medium" pitchFamily="34" charset="-120"/>
+              </a:rPr>
+              <a:t>Market size </a:t>
+            </a:r>
+            <a:pPr indent="0" marL="0">
+              <a:buNone/>
+            </a:pPr>
+            <a:r>
+              <a:rPr lang="en-US" sz="1300" baseline="30000" dirty="0">
+                <a:solidFill>
+                  <a:srgbClr val="55676B"/>
+                </a:solidFill>
+                <a:latin typeface="Geist Medium" pitchFamily="34" charset="0"/>
+                <a:ea typeface="Geist Medium" pitchFamily="34" charset="-122"/>
+                <a:cs typeface="Geist Medium" pitchFamily="34" charset="-120"/>
+              </a:rPr>
+              <a:t>2</a:t>
+            </a:r>
+            <a:endParaRPr lang="en-US" sz="1300" dirty="0"/>
+          </a:p>
+        </p:txBody>
+      </p:sp>
+      <p:sp>
+        <p:nvSpPr>
+          <p:cNvPr id="26" name="Text 23"/>
+          <p:cNvSpPr txBox="1"/>
+          <p:nvPr/>
+        </p:nvSpPr>
+        <p:spPr>
+          <a:xfrm>
+            <a:off x="6995160" y="3227832"/>
+            <a:ext cx="2377440" cy="274320"/>
           </a:xfrm>
           <a:prstGeom prst="rect">
             <a:avLst/>
@@ -1520,7 +1883,46 @@
               <a:buNone/>
             </a:pPr>
             <a:r>
-              <a:rPr lang="en-US" sz="1400" dirty="0">
+              <a:rPr lang="en-US" sz="1150" dirty="0">
+                <a:solidFill>
+                  <a:srgbClr val="8A9A9D"/>
+                </a:solidFill>
+                <a:latin typeface="Geist" pitchFamily="34" charset="0"/>
+                <a:ea typeface="Geist" pitchFamily="34" charset="-122"/>
+                <a:cs typeface="Geist" pitchFamily="34" charset="-120"/>
+              </a:rPr>
+              <a:t>firms with 50 or more staff</a:t>
+            </a:r>
+            <a:endParaRPr lang="en-US" sz="1150" dirty="0"/>
+          </a:p>
+        </p:txBody>
+      </p:sp>
+      <p:sp>
+        <p:nvSpPr>
+          <p:cNvPr id="27" name="Text 24"/>
+          <p:cNvSpPr txBox="1"/>
+          <p:nvPr/>
+        </p:nvSpPr>
+        <p:spPr>
+          <a:xfrm>
+            <a:off x="9555480" y="2926080"/>
+            <a:ext cx="2514600" cy="320040"/>
+          </a:xfrm>
+          <a:prstGeom prst="rect">
+            <a:avLst/>
+          </a:prstGeom>
+          <a:noFill/>
+          <a:ln/>
+        </p:spPr>
+        <p:txBody>
+          <a:bodyPr wrap="none" lIns="0" tIns="0" rIns="0" bIns="0" rtlCol="0" anchor="t"/>
+          <a:lstStyle/>
+          <a:p>
+            <a:pPr indent="0" marL="0">
+              <a:buNone/>
+            </a:pPr>
+            <a:r>
+              <a:rPr lang="en-US" sz="1300" dirty="0">
                 <a:solidFill>
                   <a:srgbClr val="1C2B2F"/>
                 </a:solidFill>
@@ -1528,13 +1930,13 @@
                 <a:ea typeface="Geist Medium" pitchFamily="34" charset="-122"/>
                 <a:cs typeface="Geist Medium" pitchFamily="34" charset="-120"/>
               </a:rPr>
-              <a:t>Market size </a:t>
-            </a:r>
-            <a:pPr indent="0" marL="0">
-              <a:buNone/>
-            </a:pPr>
-            <a:r>
-              <a:rPr lang="en-US" sz="1400" baseline="30000" dirty="0">
+              <a:t>Savings potential </a:t>
+            </a:r>
+            <a:pPr indent="0" marL="0">
+              <a:buNone/>
+            </a:pPr>
+            <a:r>
+              <a:rPr lang="en-US" sz="1300" baseline="30000" dirty="0">
                 <a:solidFill>
                   <a:srgbClr val="55676B"/>
                 </a:solidFill>
@@ -1542,21 +1944,21 @@
                 <a:ea typeface="Geist Medium" pitchFamily="34" charset="-122"/>
                 <a:cs typeface="Geist Medium" pitchFamily="34" charset="-120"/>
               </a:rPr>
-              <a:t>2</a:t>
-            </a:r>
-            <a:endParaRPr lang="en-US" sz="1400" dirty="0"/>
+              <a:t>3</a:t>
+            </a:r>
+            <a:endParaRPr lang="en-US" sz="1300" dirty="0"/>
           </a:p>
         </p:txBody>
       </p:sp>
       <p:sp>
         <p:nvSpPr>
-          <p:cNvPr id="16" name="Text 13"/>
+          <p:cNvPr id="28" name="Text 25"/>
           <p:cNvSpPr txBox="1"/>
           <p:nvPr/>
         </p:nvSpPr>
         <p:spPr>
           <a:xfrm>
-            <a:off x="6995160" y="3227832"/>
+            <a:off x="9555480" y="3227832"/>
             <a:ext cx="2377440" cy="274320"/>
           </a:xfrm>
           <a:prstGeom prst="rect">
@@ -1581,7 +1983,7 @@
                 <a:ea typeface="Geist" pitchFamily="34" charset="-122"/>
                 <a:cs typeface="Geist" pitchFamily="34" charset="-120"/>
               </a:rPr>
-              <a:t>firms with 50 or more staff</a:t>
+              <a:t>on lawyer cost</a:t>
             </a:r>
             <a:endParaRPr lang="en-US" sz="1150" dirty="0"/>
           </a:p>
@@ -1589,14 +1991,67 @@
       </p:sp>
       <p:sp>
         <p:nvSpPr>
-          <p:cNvPr id="17" name="Text 14"/>
+          <p:cNvPr id="29" name="Text 26"/>
           <p:cNvSpPr txBox="1"/>
           <p:nvPr/>
         </p:nvSpPr>
         <p:spPr>
           <a:xfrm>
-            <a:off x="9555480" y="2926080"/>
-            <a:ext cx="2377440" cy="320040"/>
+            <a:off x="12115800" y="2926080"/>
+            <a:ext cx="2514600" cy="320040"/>
+          </a:xfrm>
+          <a:prstGeom prst="rect">
+            <a:avLst/>
+          </a:prstGeom>
+          <a:noFill/>
+          <a:ln/>
+        </p:spPr>
+        <p:txBody>
+          <a:bodyPr wrap="none" lIns="0" tIns="0" rIns="0" bIns="0" rtlCol="0" anchor="t"/>
+          <a:lstStyle/>
+          <a:p>
+            <a:pPr indent="0" marL="0">
+              <a:buNone/>
+            </a:pPr>
+            <a:r>
+              <a:rPr lang="en-US" sz="1300" dirty="0">
+                <a:solidFill>
+                  <a:srgbClr val="1C2B2F"/>
+                </a:solidFill>
+                <a:latin typeface="Geist Medium" pitchFamily="34" charset="0"/>
+                <a:ea typeface="Geist Medium" pitchFamily="34" charset="-122"/>
+                <a:cs typeface="Geist Medium" pitchFamily="34" charset="-120"/>
+              </a:rPr>
+              <a:t>New regulation enforcement </a:t>
+            </a:r>
+            <a:pPr indent="0" marL="0">
+              <a:buNone/>
+            </a:pPr>
+            <a:r>
+              <a:rPr lang="en-US" sz="1300" baseline="30000" dirty="0">
+                <a:solidFill>
+                  <a:srgbClr val="55676B"/>
+                </a:solidFill>
+                <a:latin typeface="Geist Medium" pitchFamily="34" charset="0"/>
+                <a:ea typeface="Geist Medium" pitchFamily="34" charset="-122"/>
+                <a:cs typeface="Geist Medium" pitchFamily="34" charset="-120"/>
+              </a:rPr>
+              <a:t>4</a:t>
+            </a:r>
+            <a:endParaRPr lang="en-US" sz="1300" dirty="0"/>
+          </a:p>
+        </p:txBody>
+      </p:sp>
+      <p:sp>
+        <p:nvSpPr>
+          <p:cNvPr id="30" name="Text 27"/>
+          <p:cNvSpPr txBox="1"/>
+          <p:nvPr/>
+        </p:nvSpPr>
+        <p:spPr>
+          <a:xfrm>
+            <a:off x="12115800" y="3227832"/>
+            <a:ext cx="2377440" cy="274320"/>
           </a:xfrm>
           <a:prstGeom prst="rect">
             <a:avLst/>
@@ -1612,7 +2067,46 @@
               <a:buNone/>
             </a:pPr>
             <a:r>
-              <a:rPr lang="en-US" sz="1400" dirty="0">
+              <a:rPr lang="en-US" sz="1150" dirty="0">
+                <a:solidFill>
+                  <a:srgbClr val="8A9A9D"/>
+                </a:solidFill>
+                <a:latin typeface="Geist" pitchFamily="34" charset="0"/>
+                <a:ea typeface="Geist" pitchFamily="34" charset="-122"/>
+                <a:cs typeface="Geist" pitchFamily="34" charset="-120"/>
+              </a:rPr>
+              <a:t>deadline live, fines starting</a:t>
+            </a:r>
+            <a:endParaRPr lang="en-US" sz="1150" dirty="0"/>
+          </a:p>
+        </p:txBody>
+      </p:sp>
+      <p:sp>
+        <p:nvSpPr>
+          <p:cNvPr id="31" name="Text 28"/>
+          <p:cNvSpPr txBox="1"/>
+          <p:nvPr/>
+        </p:nvSpPr>
+        <p:spPr>
+          <a:xfrm>
+            <a:off x="14676120" y="2926080"/>
+            <a:ext cx="2468880" cy="320040"/>
+          </a:xfrm>
+          <a:prstGeom prst="rect">
+            <a:avLst/>
+          </a:prstGeom>
+          <a:noFill/>
+          <a:ln/>
+        </p:spPr>
+        <p:txBody>
+          <a:bodyPr wrap="square" lIns="0" tIns="0" rIns="0" bIns="0" rtlCol="0" anchor="t"/>
+          <a:lstStyle/>
+          <a:p>
+            <a:pPr indent="0" marL="0">
+              <a:buNone/>
+            </a:pPr>
+            <a:r>
+              <a:rPr lang="en-US" sz="1300" dirty="0">
                 <a:solidFill>
                   <a:srgbClr val="1C2B2F"/>
                 </a:solidFill>
@@ -1620,36 +2114,22 @@
                 <a:ea typeface="Geist Medium" pitchFamily="34" charset="-122"/>
                 <a:cs typeface="Geist Medium" pitchFamily="34" charset="-120"/>
               </a:rPr>
-              <a:t>Savings potential </a:t>
-            </a:r>
-            <a:pPr indent="0" marL="0">
-              <a:buNone/>
-            </a:pPr>
-            <a:r>
-              <a:rPr lang="en-US" sz="1400" baseline="30000" dirty="0">
-                <a:solidFill>
-                  <a:srgbClr val="55676B"/>
-                </a:solidFill>
-                <a:latin typeface="Geist Medium" pitchFamily="34" charset="0"/>
-                <a:ea typeface="Geist Medium" pitchFamily="34" charset="-122"/>
-                <a:cs typeface="Geist Medium" pitchFamily="34" charset="-120"/>
-              </a:rPr>
-              <a:t>3</a:t>
-            </a:r>
-            <a:endParaRPr lang="en-US" sz="1400" dirty="0"/>
+              <a:t>Total</a:t>
+            </a:r>
+            <a:endParaRPr lang="en-US" sz="1300" dirty="0"/>
           </a:p>
         </p:txBody>
       </p:sp>
       <p:sp>
         <p:nvSpPr>
-          <p:cNvPr id="18" name="Text 15"/>
+          <p:cNvPr id="32" name="Text 29"/>
           <p:cNvSpPr txBox="1"/>
           <p:nvPr/>
         </p:nvSpPr>
         <p:spPr>
           <a:xfrm>
-            <a:off x="9555480" y="3227832"/>
-            <a:ext cx="2377440" cy="274320"/>
+            <a:off x="14676120" y="3227832"/>
+            <a:ext cx="2468880" cy="274320"/>
           </a:xfrm>
           <a:prstGeom prst="rect">
             <a:avLst/>
@@ -1673,7 +2153,7 @@
                 <a:ea typeface="Geist" pitchFamily="34" charset="-122"/>
                 <a:cs typeface="Geist" pitchFamily="34" charset="-120"/>
               </a:rPr>
-              <a:t>lawyer prices</a:t>
+              <a:t>of 20</a:t>
             </a:r>
             <a:endParaRPr lang="en-US" sz="1150" dirty="0"/>
           </a:p>
@@ -1681,177 +2161,7 @@
       </p:sp>
       <p:sp>
         <p:nvSpPr>
-          <p:cNvPr id="19" name="Text 16"/>
-          <p:cNvSpPr txBox="1"/>
-          <p:nvPr/>
-        </p:nvSpPr>
-        <p:spPr>
-          <a:xfrm>
-            <a:off x="12115800" y="2926080"/>
-            <a:ext cx="2377440" cy="320040"/>
-          </a:xfrm>
-          <a:prstGeom prst="rect">
-            <a:avLst/>
-          </a:prstGeom>
-          <a:noFill/>
-          <a:ln/>
-        </p:spPr>
-        <p:txBody>
-          <a:bodyPr wrap="square" lIns="0" tIns="0" rIns="0" bIns="0" rtlCol="0" anchor="t"/>
-          <a:lstStyle/>
-          <a:p>
-            <a:pPr indent="0" marL="0">
-              <a:buNone/>
-            </a:pPr>
-            <a:r>
-              <a:rPr lang="en-US" sz="1400" dirty="0">
-                <a:solidFill>
-                  <a:srgbClr val="1C2B2F"/>
-                </a:solidFill>
-                <a:latin typeface="Geist Medium" pitchFamily="34" charset="0"/>
-                <a:ea typeface="Geist Medium" pitchFamily="34" charset="-122"/>
-                <a:cs typeface="Geist Medium" pitchFamily="34" charset="-120"/>
-              </a:rPr>
-              <a:t>Trigger freshness </a:t>
-            </a:r>
-            <a:pPr indent="0" marL="0">
-              <a:buNone/>
-            </a:pPr>
-            <a:r>
-              <a:rPr lang="en-US" sz="1400" baseline="30000" dirty="0">
-                <a:solidFill>
-                  <a:srgbClr val="55676B"/>
-                </a:solidFill>
-                <a:latin typeface="Geist Medium" pitchFamily="34" charset="0"/>
-                <a:ea typeface="Geist Medium" pitchFamily="34" charset="-122"/>
-                <a:cs typeface="Geist Medium" pitchFamily="34" charset="-120"/>
-              </a:rPr>
-              <a:t>4</a:t>
-            </a:r>
-            <a:endParaRPr lang="en-US" sz="1400" dirty="0"/>
-          </a:p>
-        </p:txBody>
-      </p:sp>
-      <p:sp>
-        <p:nvSpPr>
-          <p:cNvPr id="20" name="Text 17"/>
-          <p:cNvSpPr txBox="1"/>
-          <p:nvPr/>
-        </p:nvSpPr>
-        <p:spPr>
-          <a:xfrm>
-            <a:off x="12115800" y="3227832"/>
-            <a:ext cx="2377440" cy="274320"/>
-          </a:xfrm>
-          <a:prstGeom prst="rect">
-            <a:avLst/>
-          </a:prstGeom>
-          <a:noFill/>
-          <a:ln/>
-        </p:spPr>
-        <p:txBody>
-          <a:bodyPr wrap="square" lIns="0" tIns="0" rIns="0" bIns="0" rtlCol="0" anchor="t"/>
-          <a:lstStyle/>
-          <a:p>
-            <a:pPr indent="0" marL="0">
-              <a:buNone/>
-            </a:pPr>
-            <a:r>
-              <a:rPr lang="en-US" sz="1150" dirty="0">
-                <a:solidFill>
-                  <a:srgbClr val="8A9A9D"/>
-                </a:solidFill>
-                <a:latin typeface="Geist" pitchFamily="34" charset="0"/>
-                <a:ea typeface="Geist" pitchFamily="34" charset="-122"/>
-                <a:cs typeface="Geist" pitchFamily="34" charset="-120"/>
-              </a:rPr>
-              <a:t>NIS2 window, enforcement</a:t>
-            </a:r>
-            <a:endParaRPr lang="en-US" sz="1150" dirty="0"/>
-          </a:p>
-        </p:txBody>
-      </p:sp>
-      <p:sp>
-        <p:nvSpPr>
-          <p:cNvPr id="21" name="Text 18"/>
-          <p:cNvSpPr txBox="1"/>
-          <p:nvPr/>
-        </p:nvSpPr>
-        <p:spPr>
-          <a:xfrm>
-            <a:off x="14676120" y="2926080"/>
-            <a:ext cx="2468880" cy="320040"/>
-          </a:xfrm>
-          <a:prstGeom prst="rect">
-            <a:avLst/>
-          </a:prstGeom>
-          <a:noFill/>
-          <a:ln/>
-        </p:spPr>
-        <p:txBody>
-          <a:bodyPr wrap="square" lIns="0" tIns="0" rIns="0" bIns="0" rtlCol="0" anchor="t"/>
-          <a:lstStyle/>
-          <a:p>
-            <a:pPr indent="0" marL="0">
-              <a:buNone/>
-            </a:pPr>
-            <a:r>
-              <a:rPr lang="en-US" sz="1400" dirty="0">
-                <a:solidFill>
-                  <a:srgbClr val="1C2B2F"/>
-                </a:solidFill>
-                <a:latin typeface="Geist Medium" pitchFamily="34" charset="0"/>
-                <a:ea typeface="Geist Medium" pitchFamily="34" charset="-122"/>
-                <a:cs typeface="Geist Medium" pitchFamily="34" charset="-120"/>
-              </a:rPr>
-              <a:t>Total</a:t>
-            </a:r>
-            <a:endParaRPr lang="en-US" sz="1400" dirty="0"/>
-          </a:p>
-        </p:txBody>
-      </p:sp>
-      <p:sp>
-        <p:nvSpPr>
-          <p:cNvPr id="22" name="Text 19"/>
-          <p:cNvSpPr txBox="1"/>
-          <p:nvPr/>
-        </p:nvSpPr>
-        <p:spPr>
-          <a:xfrm>
-            <a:off x="14676120" y="3227832"/>
-            <a:ext cx="2468880" cy="274320"/>
-          </a:xfrm>
-          <a:prstGeom prst="rect">
-            <a:avLst/>
-          </a:prstGeom>
-          <a:noFill/>
-          <a:ln/>
-        </p:spPr>
-        <p:txBody>
-          <a:bodyPr wrap="square" lIns="0" tIns="0" rIns="0" bIns="0" rtlCol="0" anchor="t"/>
-          <a:lstStyle/>
-          <a:p>
-            <a:pPr indent="0" marL="0">
-              <a:buNone/>
-            </a:pPr>
-            <a:r>
-              <a:rPr lang="en-US" sz="1150" dirty="0">
-                <a:solidFill>
-                  <a:srgbClr val="8A9A9D"/>
-                </a:solidFill>
-                <a:latin typeface="Geist" pitchFamily="34" charset="0"/>
-                <a:ea typeface="Geist" pitchFamily="34" charset="-122"/>
-                <a:cs typeface="Geist" pitchFamily="34" charset="-120"/>
-              </a:rPr>
-              <a:t>of 20</a:t>
-            </a:r>
-            <a:endParaRPr lang="en-US" sz="1150" dirty="0"/>
-          </a:p>
-        </p:txBody>
-      </p:sp>
-      <p:sp>
-        <p:nvSpPr>
-          <p:cNvPr id="23" name="Shape 20"/>
+          <p:cNvPr id="33" name="Shape 30"/>
           <p:cNvSpPr/>
           <p:nvPr/>
         </p:nvSpPr>
@@ -1874,7 +2184,7 @@
       </p:sp>
       <p:sp>
         <p:nvSpPr>
-          <p:cNvPr id="24" name="Shape 21"/>
+          <p:cNvPr id="34" name="Shape 31"/>
           <p:cNvSpPr/>
           <p:nvPr/>
         </p:nvSpPr>
@@ -1901,7 +2211,7 @@
       </p:sp>
       <p:sp>
         <p:nvSpPr>
-          <p:cNvPr id="25" name="Shape 22"/>
+          <p:cNvPr id="35" name="Shape 32"/>
           <p:cNvSpPr/>
           <p:nvPr/>
         </p:nvSpPr>
@@ -1926,7 +2236,7 @@
       </p:sp>
       <p:sp>
         <p:nvSpPr>
-          <p:cNvPr id="26" name="Text 23"/>
+          <p:cNvPr id="36" name="Text 33"/>
           <p:cNvSpPr txBox="1"/>
           <p:nvPr/>
         </p:nvSpPr>
@@ -1965,7 +2275,7 @@
       </p:sp>
       <p:sp>
         <p:nvSpPr>
-          <p:cNvPr id="27" name="Text 24"/>
+          <p:cNvPr id="37" name="Text 34"/>
           <p:cNvSpPr txBox="1"/>
           <p:nvPr/>
         </p:nvSpPr>
@@ -2004,7 +2314,7 @@
       </p:sp>
       <p:sp>
         <p:nvSpPr>
-          <p:cNvPr id="28" name="Text 25"/>
+          <p:cNvPr id="38" name="Text 35"/>
           <p:cNvSpPr txBox="1"/>
           <p:nvPr/>
         </p:nvSpPr>
@@ -2043,7 +2353,7 @@
       </p:sp>
       <p:sp>
         <p:nvSpPr>
-          <p:cNvPr id="29" name="Shape 26"/>
+          <p:cNvPr id="39" name="Shape 36"/>
           <p:cNvSpPr/>
           <p:nvPr/>
         </p:nvSpPr>
@@ -2068,7 +2378,7 @@
       </p:sp>
       <p:sp>
         <p:nvSpPr>
-          <p:cNvPr id="30" name="Shape 27"/>
+          <p:cNvPr id="40" name="Shape 37"/>
           <p:cNvSpPr/>
           <p:nvPr/>
         </p:nvSpPr>
@@ -2093,7 +2403,7 @@
       </p:sp>
       <p:sp>
         <p:nvSpPr>
-          <p:cNvPr id="31" name="Shape 28"/>
+          <p:cNvPr id="41" name="Shape 38"/>
           <p:cNvSpPr/>
           <p:nvPr/>
         </p:nvSpPr>
@@ -2118,7 +2428,7 @@
       </p:sp>
       <p:sp>
         <p:nvSpPr>
-          <p:cNvPr id="32" name="Shape 29"/>
+          <p:cNvPr id="42" name="Shape 39"/>
           <p:cNvSpPr/>
           <p:nvPr/>
         </p:nvSpPr>
@@ -2143,7 +2453,7 @@
       </p:sp>
       <p:sp>
         <p:nvSpPr>
-          <p:cNvPr id="33" name="Shape 30"/>
+          <p:cNvPr id="43" name="Shape 40"/>
           <p:cNvSpPr/>
           <p:nvPr/>
         </p:nvSpPr>
@@ -2168,7 +2478,7 @@
       </p:sp>
       <p:sp>
         <p:nvSpPr>
-          <p:cNvPr id="34" name="Text 31"/>
+          <p:cNvPr id="44" name="Text 41"/>
           <p:cNvSpPr txBox="1"/>
           <p:nvPr/>
         </p:nvSpPr>
@@ -2207,7 +2517,7 @@
       </p:sp>
       <p:sp>
         <p:nvSpPr>
-          <p:cNvPr id="35" name="Shape 32"/>
+          <p:cNvPr id="45" name="Shape 42"/>
           <p:cNvSpPr/>
           <p:nvPr/>
         </p:nvSpPr>
@@ -2232,7 +2542,7 @@
       </p:sp>
       <p:sp>
         <p:nvSpPr>
-          <p:cNvPr id="36" name="Shape 33"/>
+          <p:cNvPr id="46" name="Shape 43"/>
           <p:cNvSpPr/>
           <p:nvPr/>
         </p:nvSpPr>
@@ -2257,7 +2567,7 @@
       </p:sp>
       <p:sp>
         <p:nvSpPr>
-          <p:cNvPr id="37" name="Shape 34"/>
+          <p:cNvPr id="47" name="Shape 44"/>
           <p:cNvSpPr/>
           <p:nvPr/>
         </p:nvSpPr>
@@ -2282,7 +2592,7 @@
       </p:sp>
       <p:sp>
         <p:nvSpPr>
-          <p:cNvPr id="38" name="Shape 35"/>
+          <p:cNvPr id="48" name="Shape 45"/>
           <p:cNvSpPr/>
           <p:nvPr/>
         </p:nvSpPr>
@@ -2307,7 +2617,7 @@
       </p:sp>
       <p:sp>
         <p:nvSpPr>
-          <p:cNvPr id="39" name="Shape 36"/>
+          <p:cNvPr id="49" name="Shape 46"/>
           <p:cNvSpPr/>
           <p:nvPr/>
         </p:nvSpPr>
@@ -2332,7 +2642,7 @@
       </p:sp>
       <p:sp>
         <p:nvSpPr>
-          <p:cNvPr id="40" name="Text 37"/>
+          <p:cNvPr id="50" name="Text 47"/>
           <p:cNvSpPr txBox="1"/>
           <p:nvPr/>
         </p:nvSpPr>
@@ -2371,7 +2681,7 @@
       </p:sp>
       <p:sp>
         <p:nvSpPr>
-          <p:cNvPr id="41" name="Shape 38"/>
+          <p:cNvPr id="51" name="Shape 48"/>
           <p:cNvSpPr/>
           <p:nvPr/>
         </p:nvSpPr>
@@ -2396,7 +2706,7 @@
       </p:sp>
       <p:sp>
         <p:nvSpPr>
-          <p:cNvPr id="42" name="Shape 39"/>
+          <p:cNvPr id="52" name="Shape 49"/>
           <p:cNvSpPr/>
           <p:nvPr/>
         </p:nvSpPr>
@@ -2421,7 +2731,7 @@
       </p:sp>
       <p:sp>
         <p:nvSpPr>
-          <p:cNvPr id="43" name="Shape 40"/>
+          <p:cNvPr id="53" name="Shape 50"/>
           <p:cNvSpPr/>
           <p:nvPr/>
         </p:nvSpPr>
@@ -2446,7 +2756,7 @@
       </p:sp>
       <p:sp>
         <p:nvSpPr>
-          <p:cNvPr id="44" name="Shape 41"/>
+          <p:cNvPr id="54" name="Shape 51"/>
           <p:cNvSpPr/>
           <p:nvPr/>
         </p:nvSpPr>
@@ -2471,7 +2781,7 @@
       </p:sp>
       <p:sp>
         <p:nvSpPr>
-          <p:cNvPr id="45" name="Shape 42"/>
+          <p:cNvPr id="55" name="Shape 52"/>
           <p:cNvSpPr/>
           <p:nvPr/>
         </p:nvSpPr>
@@ -2496,7 +2806,7 @@
       </p:sp>
       <p:sp>
         <p:nvSpPr>
-          <p:cNvPr id="46" name="Text 43"/>
+          <p:cNvPr id="56" name="Text 53"/>
           <p:cNvSpPr txBox="1"/>
           <p:nvPr/>
         </p:nvSpPr>
@@ -2535,7 +2845,7 @@
       </p:sp>
       <p:sp>
         <p:nvSpPr>
-          <p:cNvPr id="47" name="Shape 44"/>
+          <p:cNvPr id="57" name="Shape 54"/>
           <p:cNvSpPr/>
           <p:nvPr/>
         </p:nvSpPr>
@@ -2560,7 +2870,7 @@
       </p:sp>
       <p:sp>
         <p:nvSpPr>
-          <p:cNvPr id="48" name="Shape 45"/>
+          <p:cNvPr id="58" name="Shape 55"/>
           <p:cNvSpPr/>
           <p:nvPr/>
         </p:nvSpPr>
@@ -2585,7 +2895,7 @@
       </p:sp>
       <p:sp>
         <p:nvSpPr>
-          <p:cNvPr id="49" name="Shape 46"/>
+          <p:cNvPr id="59" name="Shape 56"/>
           <p:cNvSpPr/>
           <p:nvPr/>
         </p:nvSpPr>
@@ -2610,7 +2920,7 @@
       </p:sp>
       <p:sp>
         <p:nvSpPr>
-          <p:cNvPr id="50" name="Shape 47"/>
+          <p:cNvPr id="60" name="Shape 57"/>
           <p:cNvSpPr/>
           <p:nvPr/>
         </p:nvSpPr>
@@ -2635,7 +2945,7 @@
       </p:sp>
       <p:sp>
         <p:nvSpPr>
-          <p:cNvPr id="51" name="Shape 48"/>
+          <p:cNvPr id="61" name="Shape 58"/>
           <p:cNvSpPr/>
           <p:nvPr/>
         </p:nvSpPr>
@@ -2660,7 +2970,7 @@
       </p:sp>
       <p:sp>
         <p:nvSpPr>
-          <p:cNvPr id="52" name="Text 49"/>
+          <p:cNvPr id="62" name="Text 59"/>
           <p:cNvSpPr txBox="1"/>
           <p:nvPr/>
         </p:nvSpPr>
@@ -2699,7 +3009,7 @@
       </p:sp>
       <p:sp>
         <p:nvSpPr>
-          <p:cNvPr id="53" name="Shape 50"/>
+          <p:cNvPr id="63" name="Shape 60"/>
           <p:cNvSpPr/>
           <p:nvPr/>
         </p:nvSpPr>
@@ -2726,7 +3036,7 @@
       </p:sp>
       <p:sp>
         <p:nvSpPr>
-          <p:cNvPr id="54" name="Shape 51"/>
+          <p:cNvPr id="64" name="Shape 61"/>
           <p:cNvSpPr/>
           <p:nvPr/>
         </p:nvSpPr>
@@ -2753,7 +3063,7 @@
       </p:sp>
       <p:sp>
         <p:nvSpPr>
-          <p:cNvPr id="55" name="Shape 52"/>
+          <p:cNvPr id="65" name="Shape 62"/>
           <p:cNvSpPr/>
           <p:nvPr/>
         </p:nvSpPr>
@@ -2780,7 +3090,7 @@
       </p:sp>
       <p:sp>
         <p:nvSpPr>
-          <p:cNvPr id="56" name="Shape 53"/>
+          <p:cNvPr id="66" name="Shape 63"/>
           <p:cNvSpPr/>
           <p:nvPr/>
         </p:nvSpPr>
@@ -2805,7 +3115,7 @@
       </p:sp>
       <p:sp>
         <p:nvSpPr>
-          <p:cNvPr id="57" name="Text 54"/>
+          <p:cNvPr id="67" name="Text 64"/>
           <p:cNvSpPr txBox="1"/>
           <p:nvPr/>
         </p:nvSpPr>
@@ -2844,7 +3154,7 @@
       </p:sp>
       <p:sp>
         <p:nvSpPr>
-          <p:cNvPr id="58" name="Text 55"/>
+          <p:cNvPr id="68" name="Text 65"/>
           <p:cNvSpPr txBox="1"/>
           <p:nvPr/>
         </p:nvSpPr>
@@ -2883,7 +3193,7 @@
       </p:sp>
       <p:sp>
         <p:nvSpPr>
-          <p:cNvPr id="59" name="Text 56"/>
+          <p:cNvPr id="69" name="Text 66"/>
           <p:cNvSpPr txBox="1"/>
           <p:nvPr/>
         </p:nvSpPr>
@@ -2922,7 +3232,7 @@
       </p:sp>
       <p:sp>
         <p:nvSpPr>
-          <p:cNvPr id="60" name="Shape 57"/>
+          <p:cNvPr id="70" name="Shape 67"/>
           <p:cNvSpPr/>
           <p:nvPr/>
         </p:nvSpPr>
@@ -2947,7 +3257,7 @@
       </p:sp>
       <p:sp>
         <p:nvSpPr>
-          <p:cNvPr id="61" name="Shape 58"/>
+          <p:cNvPr id="71" name="Shape 68"/>
           <p:cNvSpPr/>
           <p:nvPr/>
         </p:nvSpPr>
@@ -2972,7 +3282,7 @@
       </p:sp>
       <p:sp>
         <p:nvSpPr>
-          <p:cNvPr id="62" name="Shape 59"/>
+          <p:cNvPr id="72" name="Shape 69"/>
           <p:cNvSpPr/>
           <p:nvPr/>
         </p:nvSpPr>
@@ -2997,7 +3307,7 @@
       </p:sp>
       <p:sp>
         <p:nvSpPr>
-          <p:cNvPr id="63" name="Shape 60"/>
+          <p:cNvPr id="73" name="Shape 70"/>
           <p:cNvSpPr/>
           <p:nvPr/>
         </p:nvSpPr>
@@ -3022,7 +3332,7 @@
       </p:sp>
       <p:sp>
         <p:nvSpPr>
-          <p:cNvPr id="64" name="Shape 61"/>
+          <p:cNvPr id="74" name="Shape 71"/>
           <p:cNvSpPr/>
           <p:nvPr/>
         </p:nvSpPr>
@@ -3047,7 +3357,7 @@
       </p:sp>
       <p:sp>
         <p:nvSpPr>
-          <p:cNvPr id="65" name="Text 62"/>
+          <p:cNvPr id="75" name="Text 72"/>
           <p:cNvSpPr txBox="1"/>
           <p:nvPr/>
         </p:nvSpPr>
@@ -3086,7 +3396,7 @@
       </p:sp>
       <p:sp>
         <p:nvSpPr>
-          <p:cNvPr id="66" name="Shape 63"/>
+          <p:cNvPr id="76" name="Shape 73"/>
           <p:cNvSpPr/>
           <p:nvPr/>
         </p:nvSpPr>
@@ -3111,7 +3421,7 @@
       </p:sp>
       <p:sp>
         <p:nvSpPr>
-          <p:cNvPr id="67" name="Shape 64"/>
+          <p:cNvPr id="77" name="Shape 74"/>
           <p:cNvSpPr/>
           <p:nvPr/>
         </p:nvSpPr>
@@ -3136,7 +3446,7 @@
       </p:sp>
       <p:sp>
         <p:nvSpPr>
-          <p:cNvPr id="68" name="Shape 65"/>
+          <p:cNvPr id="78" name="Shape 75"/>
           <p:cNvSpPr/>
           <p:nvPr/>
         </p:nvSpPr>
@@ -3161,7 +3471,7 @@
       </p:sp>
       <p:sp>
         <p:nvSpPr>
-          <p:cNvPr id="69" name="Shape 66"/>
+          <p:cNvPr id="79" name="Shape 76"/>
           <p:cNvSpPr/>
           <p:nvPr/>
         </p:nvSpPr>
@@ -3186,7 +3496,7 @@
       </p:sp>
       <p:sp>
         <p:nvSpPr>
-          <p:cNvPr id="70" name="Shape 67"/>
+          <p:cNvPr id="80" name="Shape 77"/>
           <p:cNvSpPr/>
           <p:nvPr/>
         </p:nvSpPr>
@@ -3211,7 +3521,7 @@
       </p:sp>
       <p:sp>
         <p:nvSpPr>
-          <p:cNvPr id="71" name="Text 68"/>
+          <p:cNvPr id="81" name="Text 78"/>
           <p:cNvSpPr txBox="1"/>
           <p:nvPr/>
         </p:nvSpPr>
@@ -3250,7 +3560,7 @@
       </p:sp>
       <p:sp>
         <p:nvSpPr>
-          <p:cNvPr id="72" name="Shape 69"/>
+          <p:cNvPr id="82" name="Shape 79"/>
           <p:cNvSpPr/>
           <p:nvPr/>
         </p:nvSpPr>
@@ -3275,7 +3585,7 @@
       </p:sp>
       <p:sp>
         <p:nvSpPr>
-          <p:cNvPr id="73" name="Shape 70"/>
+          <p:cNvPr id="83" name="Shape 80"/>
           <p:cNvSpPr/>
           <p:nvPr/>
         </p:nvSpPr>
@@ -3300,7 +3610,7 @@
       </p:sp>
       <p:sp>
         <p:nvSpPr>
-          <p:cNvPr id="74" name="Shape 71"/>
+          <p:cNvPr id="84" name="Shape 81"/>
           <p:cNvSpPr/>
           <p:nvPr/>
         </p:nvSpPr>
@@ -3325,7 +3635,7 @@
       </p:sp>
       <p:sp>
         <p:nvSpPr>
-          <p:cNvPr id="75" name="Shape 72"/>
+          <p:cNvPr id="85" name="Shape 82"/>
           <p:cNvSpPr/>
           <p:nvPr/>
         </p:nvSpPr>
@@ -3350,7 +3660,7 @@
       </p:sp>
       <p:sp>
         <p:nvSpPr>
-          <p:cNvPr id="76" name="Shape 73"/>
+          <p:cNvPr id="86" name="Shape 83"/>
           <p:cNvSpPr/>
           <p:nvPr/>
         </p:nvSpPr>
@@ -3375,7 +3685,7 @@
       </p:sp>
       <p:sp>
         <p:nvSpPr>
-          <p:cNvPr id="77" name="Text 74"/>
+          <p:cNvPr id="87" name="Text 84"/>
           <p:cNvSpPr txBox="1"/>
           <p:nvPr/>
         </p:nvSpPr>
@@ -3414,7 +3724,7 @@
       </p:sp>
       <p:sp>
         <p:nvSpPr>
-          <p:cNvPr id="78" name="Shape 75"/>
+          <p:cNvPr id="88" name="Shape 85"/>
           <p:cNvSpPr/>
           <p:nvPr/>
         </p:nvSpPr>
@@ -3439,7 +3749,7 @@
       </p:sp>
       <p:sp>
         <p:nvSpPr>
-          <p:cNvPr id="79" name="Shape 76"/>
+          <p:cNvPr id="89" name="Shape 86"/>
           <p:cNvSpPr/>
           <p:nvPr/>
         </p:nvSpPr>
@@ -3464,7 +3774,7 @@
       </p:sp>
       <p:sp>
         <p:nvSpPr>
-          <p:cNvPr id="80" name="Shape 77"/>
+          <p:cNvPr id="90" name="Shape 87"/>
           <p:cNvSpPr/>
           <p:nvPr/>
         </p:nvSpPr>
@@ -3489,7 +3799,7 @@
       </p:sp>
       <p:sp>
         <p:nvSpPr>
-          <p:cNvPr id="81" name="Shape 78"/>
+          <p:cNvPr id="91" name="Shape 88"/>
           <p:cNvSpPr/>
           <p:nvPr/>
         </p:nvSpPr>
@@ -3514,7 +3824,7 @@
       </p:sp>
       <p:sp>
         <p:nvSpPr>
-          <p:cNvPr id="82" name="Shape 79"/>
+          <p:cNvPr id="92" name="Shape 89"/>
           <p:cNvSpPr/>
           <p:nvPr/>
         </p:nvSpPr>
@@ -3539,7 +3849,7 @@
       </p:sp>
       <p:sp>
         <p:nvSpPr>
-          <p:cNvPr id="83" name="Text 80"/>
+          <p:cNvPr id="93" name="Text 90"/>
           <p:cNvSpPr txBox="1"/>
           <p:nvPr/>
         </p:nvSpPr>
@@ -3578,7 +3888,7 @@
       </p:sp>
       <p:sp>
         <p:nvSpPr>
-          <p:cNvPr id="84" name="Shape 81"/>
+          <p:cNvPr id="94" name="Shape 91"/>
           <p:cNvSpPr/>
           <p:nvPr/>
         </p:nvSpPr>
@@ -3605,7 +3915,7 @@
       </p:sp>
       <p:sp>
         <p:nvSpPr>
-          <p:cNvPr id="85" name="Shape 82"/>
+          <p:cNvPr id="95" name="Shape 92"/>
           <p:cNvSpPr/>
           <p:nvPr/>
         </p:nvSpPr>
@@ -3632,7 +3942,7 @@
       </p:sp>
       <p:sp>
         <p:nvSpPr>
-          <p:cNvPr id="86" name="Shape 83"/>
+          <p:cNvPr id="96" name="Shape 93"/>
           <p:cNvSpPr/>
           <p:nvPr/>
         </p:nvSpPr>
@@ -3659,7 +3969,7 @@
       </p:sp>
       <p:sp>
         <p:nvSpPr>
-          <p:cNvPr id="87" name="Shape 84"/>
+          <p:cNvPr id="97" name="Shape 94"/>
           <p:cNvSpPr/>
           <p:nvPr/>
         </p:nvSpPr>
@@ -3684,7 +3994,7 @@
       </p:sp>
       <p:sp>
         <p:nvSpPr>
-          <p:cNvPr id="88" name="Text 85"/>
+          <p:cNvPr id="98" name="Text 95"/>
           <p:cNvSpPr txBox="1"/>
           <p:nvPr/>
         </p:nvSpPr>
@@ -3723,7 +4033,7 @@
       </p:sp>
       <p:sp>
         <p:nvSpPr>
-          <p:cNvPr id="89" name="Text 86"/>
+          <p:cNvPr id="99" name="Text 96"/>
           <p:cNvSpPr txBox="1"/>
           <p:nvPr/>
         </p:nvSpPr>
@@ -3762,7 +4072,7 @@
       </p:sp>
       <p:sp>
         <p:nvSpPr>
-          <p:cNvPr id="90" name="Text 87"/>
+          <p:cNvPr id="100" name="Text 97"/>
           <p:cNvSpPr txBox="1"/>
           <p:nvPr/>
         </p:nvSpPr>
@@ -3801,7 +4111,7 @@
       </p:sp>
       <p:sp>
         <p:nvSpPr>
-          <p:cNvPr id="91" name="Shape 88"/>
+          <p:cNvPr id="101" name="Shape 98"/>
           <p:cNvSpPr/>
           <p:nvPr/>
         </p:nvSpPr>
@@ -3826,7 +4136,7 @@
       </p:sp>
       <p:sp>
         <p:nvSpPr>
-          <p:cNvPr id="92" name="Shape 89"/>
+          <p:cNvPr id="102" name="Shape 99"/>
           <p:cNvSpPr/>
           <p:nvPr/>
         </p:nvSpPr>
@@ -3851,7 +4161,7 @@
       </p:sp>
       <p:sp>
         <p:nvSpPr>
-          <p:cNvPr id="93" name="Shape 90"/>
+          <p:cNvPr id="103" name="Shape 100"/>
           <p:cNvSpPr/>
           <p:nvPr/>
         </p:nvSpPr>
@@ -3876,7 +4186,7 @@
       </p:sp>
       <p:sp>
         <p:nvSpPr>
-          <p:cNvPr id="94" name="Shape 91"/>
+          <p:cNvPr id="104" name="Shape 101"/>
           <p:cNvSpPr/>
           <p:nvPr/>
         </p:nvSpPr>
@@ -3901,7 +4211,7 @@
       </p:sp>
       <p:sp>
         <p:nvSpPr>
-          <p:cNvPr id="95" name="Shape 92"/>
+          <p:cNvPr id="105" name="Shape 102"/>
           <p:cNvSpPr/>
           <p:nvPr/>
         </p:nvSpPr>
@@ -3926,7 +4236,7 @@
       </p:sp>
       <p:sp>
         <p:nvSpPr>
-          <p:cNvPr id="96" name="Text 93"/>
+          <p:cNvPr id="106" name="Text 103"/>
           <p:cNvSpPr txBox="1"/>
           <p:nvPr/>
         </p:nvSpPr>
@@ -3965,7 +4275,7 @@
       </p:sp>
       <p:sp>
         <p:nvSpPr>
-          <p:cNvPr id="97" name="Shape 94"/>
+          <p:cNvPr id="107" name="Shape 104"/>
           <p:cNvSpPr/>
           <p:nvPr/>
         </p:nvSpPr>
@@ -3990,7 +4300,7 @@
       </p:sp>
       <p:sp>
         <p:nvSpPr>
-          <p:cNvPr id="98" name="Shape 95"/>
+          <p:cNvPr id="108" name="Shape 105"/>
           <p:cNvSpPr/>
           <p:nvPr/>
         </p:nvSpPr>
@@ -4015,7 +4325,7 @@
       </p:sp>
       <p:sp>
         <p:nvSpPr>
-          <p:cNvPr id="99" name="Shape 96"/>
+          <p:cNvPr id="109" name="Shape 106"/>
           <p:cNvSpPr/>
           <p:nvPr/>
         </p:nvSpPr>
@@ -4040,7 +4350,7 @@
       </p:sp>
       <p:sp>
         <p:nvSpPr>
-          <p:cNvPr id="100" name="Shape 97"/>
+          <p:cNvPr id="110" name="Shape 107"/>
           <p:cNvSpPr/>
           <p:nvPr/>
         </p:nvSpPr>
@@ -4065,7 +4375,7 @@
       </p:sp>
       <p:sp>
         <p:nvSpPr>
-          <p:cNvPr id="101" name="Shape 98"/>
+          <p:cNvPr id="111" name="Shape 108"/>
           <p:cNvSpPr/>
           <p:nvPr/>
         </p:nvSpPr>
@@ -4090,7 +4400,7 @@
       </p:sp>
       <p:sp>
         <p:nvSpPr>
-          <p:cNvPr id="102" name="Text 99"/>
+          <p:cNvPr id="112" name="Text 109"/>
           <p:cNvSpPr txBox="1"/>
           <p:nvPr/>
         </p:nvSpPr>
@@ -4129,7 +4439,7 @@
       </p:sp>
       <p:sp>
         <p:nvSpPr>
-          <p:cNvPr id="103" name="Shape 100"/>
+          <p:cNvPr id="113" name="Shape 110"/>
           <p:cNvSpPr/>
           <p:nvPr/>
         </p:nvSpPr>
@@ -4154,7 +4464,7 @@
       </p:sp>
       <p:sp>
         <p:nvSpPr>
-          <p:cNvPr id="104" name="Shape 101"/>
+          <p:cNvPr id="114" name="Shape 111"/>
           <p:cNvSpPr/>
           <p:nvPr/>
         </p:nvSpPr>
@@ -4179,7 +4489,7 @@
       </p:sp>
       <p:sp>
         <p:nvSpPr>
-          <p:cNvPr id="105" name="Shape 102"/>
+          <p:cNvPr id="115" name="Shape 112"/>
           <p:cNvSpPr/>
           <p:nvPr/>
         </p:nvSpPr>
@@ -4204,7 +4514,7 @@
       </p:sp>
       <p:sp>
         <p:nvSpPr>
-          <p:cNvPr id="106" name="Shape 103"/>
+          <p:cNvPr id="116" name="Shape 113"/>
           <p:cNvSpPr/>
           <p:nvPr/>
         </p:nvSpPr>
@@ -4229,7 +4539,7 @@
       </p:sp>
       <p:sp>
         <p:nvSpPr>
-          <p:cNvPr id="107" name="Shape 104"/>
+          <p:cNvPr id="117" name="Shape 114"/>
           <p:cNvSpPr/>
           <p:nvPr/>
         </p:nvSpPr>
@@ -4254,7 +4564,7 @@
       </p:sp>
       <p:sp>
         <p:nvSpPr>
-          <p:cNvPr id="108" name="Text 105"/>
+          <p:cNvPr id="118" name="Text 115"/>
           <p:cNvSpPr txBox="1"/>
           <p:nvPr/>
         </p:nvSpPr>
@@ -4293,7 +4603,7 @@
       </p:sp>
       <p:sp>
         <p:nvSpPr>
-          <p:cNvPr id="109" name="Shape 106"/>
+          <p:cNvPr id="119" name="Shape 116"/>
           <p:cNvSpPr/>
           <p:nvPr/>
         </p:nvSpPr>
@@ -4318,7 +4628,7 @@
       </p:sp>
       <p:sp>
         <p:nvSpPr>
-          <p:cNvPr id="110" name="Shape 107"/>
+          <p:cNvPr id="120" name="Shape 117"/>
           <p:cNvSpPr/>
           <p:nvPr/>
         </p:nvSpPr>
@@ -4343,7 +4653,7 @@
       </p:sp>
       <p:sp>
         <p:nvSpPr>
-          <p:cNvPr id="111" name="Shape 108"/>
+          <p:cNvPr id="121" name="Shape 118"/>
           <p:cNvSpPr/>
           <p:nvPr/>
         </p:nvSpPr>
@@ -4368,7 +4678,7 @@
       </p:sp>
       <p:sp>
         <p:nvSpPr>
-          <p:cNvPr id="112" name="Shape 109"/>
+          <p:cNvPr id="122" name="Shape 119"/>
           <p:cNvSpPr/>
           <p:nvPr/>
         </p:nvSpPr>
@@ -4393,7 +4703,7 @@
       </p:sp>
       <p:sp>
         <p:nvSpPr>
-          <p:cNvPr id="113" name="Shape 110"/>
+          <p:cNvPr id="123" name="Shape 120"/>
           <p:cNvSpPr/>
           <p:nvPr/>
         </p:nvSpPr>
@@ -4418,7 +4728,7 @@
       </p:sp>
       <p:sp>
         <p:nvSpPr>
-          <p:cNvPr id="114" name="Text 111"/>
+          <p:cNvPr id="124" name="Text 121"/>
           <p:cNvSpPr txBox="1"/>
           <p:nvPr/>
         </p:nvSpPr>
@@ -4457,7 +4767,7 @@
       </p:sp>
       <p:sp>
         <p:nvSpPr>
-          <p:cNvPr id="115" name="Shape 112"/>
+          <p:cNvPr id="125" name="Shape 122"/>
           <p:cNvSpPr/>
           <p:nvPr/>
         </p:nvSpPr>
@@ -4484,7 +4794,7 @@
       </p:sp>
       <p:sp>
         <p:nvSpPr>
-          <p:cNvPr id="116" name="Shape 113"/>
+          <p:cNvPr id="126" name="Shape 123"/>
           <p:cNvSpPr/>
           <p:nvPr/>
         </p:nvSpPr>
@@ -4511,7 +4821,7 @@
       </p:sp>
       <p:sp>
         <p:nvSpPr>
-          <p:cNvPr id="117" name="Shape 114"/>
+          <p:cNvPr id="127" name="Shape 124"/>
           <p:cNvSpPr/>
           <p:nvPr/>
         </p:nvSpPr>
@@ -4538,7 +4848,7 @@
       </p:sp>
       <p:sp>
         <p:nvSpPr>
-          <p:cNvPr id="118" name="Shape 115"/>
+          <p:cNvPr id="128" name="Shape 125"/>
           <p:cNvSpPr/>
           <p:nvPr/>
         </p:nvSpPr>
@@ -4563,7 +4873,7 @@
       </p:sp>
       <p:sp>
         <p:nvSpPr>
-          <p:cNvPr id="119" name="Text 116"/>
+          <p:cNvPr id="129" name="Text 126"/>
           <p:cNvSpPr txBox="1"/>
           <p:nvPr/>
         </p:nvSpPr>
@@ -4602,7 +4912,7 @@
       </p:sp>
       <p:sp>
         <p:nvSpPr>
-          <p:cNvPr id="120" name="Text 117"/>
+          <p:cNvPr id="130" name="Text 127"/>
           <p:cNvSpPr txBox="1"/>
           <p:nvPr/>
         </p:nvSpPr>
@@ -4641,7 +4951,7 @@
       </p:sp>
       <p:sp>
         <p:nvSpPr>
-          <p:cNvPr id="121" name="Text 118"/>
+          <p:cNvPr id="131" name="Text 128"/>
           <p:cNvSpPr txBox="1"/>
           <p:nvPr/>
         </p:nvSpPr>
@@ -4680,7 +4990,7 @@
       </p:sp>
       <p:sp>
         <p:nvSpPr>
-          <p:cNvPr id="122" name="Shape 119"/>
+          <p:cNvPr id="132" name="Shape 129"/>
           <p:cNvSpPr/>
           <p:nvPr/>
         </p:nvSpPr>
@@ -4705,7 +5015,7 @@
       </p:sp>
       <p:sp>
         <p:nvSpPr>
-          <p:cNvPr id="123" name="Shape 120"/>
+          <p:cNvPr id="133" name="Shape 130"/>
           <p:cNvSpPr/>
           <p:nvPr/>
         </p:nvSpPr>
@@ -4730,7 +5040,7 @@
       </p:sp>
       <p:sp>
         <p:nvSpPr>
-          <p:cNvPr id="124" name="Shape 121"/>
+          <p:cNvPr id="134" name="Shape 131"/>
           <p:cNvSpPr/>
           <p:nvPr/>
         </p:nvSpPr>
@@ -4755,7 +5065,7 @@
       </p:sp>
       <p:sp>
         <p:nvSpPr>
-          <p:cNvPr id="125" name="Shape 122"/>
+          <p:cNvPr id="135" name="Shape 132"/>
           <p:cNvSpPr/>
           <p:nvPr/>
         </p:nvSpPr>
@@ -4780,7 +5090,7 @@
       </p:sp>
       <p:sp>
         <p:nvSpPr>
-          <p:cNvPr id="126" name="Shape 123"/>
+          <p:cNvPr id="136" name="Shape 133"/>
           <p:cNvSpPr/>
           <p:nvPr/>
         </p:nvSpPr>
@@ -4805,7 +5115,7 @@
       </p:sp>
       <p:sp>
         <p:nvSpPr>
-          <p:cNvPr id="127" name="Text 124"/>
+          <p:cNvPr id="137" name="Text 134"/>
           <p:cNvSpPr txBox="1"/>
           <p:nvPr/>
         </p:nvSpPr>
@@ -4844,7 +5154,7 @@
       </p:sp>
       <p:sp>
         <p:nvSpPr>
-          <p:cNvPr id="128" name="Shape 125"/>
+          <p:cNvPr id="138" name="Shape 135"/>
           <p:cNvSpPr/>
           <p:nvPr/>
         </p:nvSpPr>
@@ -4869,7 +5179,7 @@
       </p:sp>
       <p:sp>
         <p:nvSpPr>
-          <p:cNvPr id="129" name="Shape 126"/>
+          <p:cNvPr id="139" name="Shape 136"/>
           <p:cNvSpPr/>
           <p:nvPr/>
         </p:nvSpPr>
@@ -4894,7 +5204,7 @@
       </p:sp>
       <p:sp>
         <p:nvSpPr>
-          <p:cNvPr id="130" name="Shape 127"/>
+          <p:cNvPr id="140" name="Shape 137"/>
           <p:cNvSpPr/>
           <p:nvPr/>
         </p:nvSpPr>
@@ -4919,7 +5229,7 @@
       </p:sp>
       <p:sp>
         <p:nvSpPr>
-          <p:cNvPr id="131" name="Shape 128"/>
+          <p:cNvPr id="141" name="Shape 138"/>
           <p:cNvSpPr/>
           <p:nvPr/>
         </p:nvSpPr>
@@ -4944,7 +5254,7 @@
       </p:sp>
       <p:sp>
         <p:nvSpPr>
-          <p:cNvPr id="132" name="Shape 129"/>
+          <p:cNvPr id="142" name="Shape 139"/>
           <p:cNvSpPr/>
           <p:nvPr/>
         </p:nvSpPr>
@@ -4969,7 +5279,7 @@
       </p:sp>
       <p:sp>
         <p:nvSpPr>
-          <p:cNvPr id="133" name="Text 130"/>
+          <p:cNvPr id="143" name="Text 140"/>
           <p:cNvSpPr txBox="1"/>
           <p:nvPr/>
         </p:nvSpPr>
@@ -5008,7 +5318,7 @@
       </p:sp>
       <p:sp>
         <p:nvSpPr>
-          <p:cNvPr id="134" name="Shape 131"/>
+          <p:cNvPr id="144" name="Shape 141"/>
           <p:cNvSpPr/>
           <p:nvPr/>
         </p:nvSpPr>
@@ -5033,7 +5343,7 @@
       </p:sp>
       <p:sp>
         <p:nvSpPr>
-          <p:cNvPr id="135" name="Shape 132"/>
+          <p:cNvPr id="145" name="Shape 142"/>
           <p:cNvSpPr/>
           <p:nvPr/>
         </p:nvSpPr>
@@ -5058,7 +5368,7 @@
       </p:sp>
       <p:sp>
         <p:nvSpPr>
-          <p:cNvPr id="136" name="Shape 133"/>
+          <p:cNvPr id="146" name="Shape 143"/>
           <p:cNvSpPr/>
           <p:nvPr/>
         </p:nvSpPr>
@@ -5083,7 +5393,7 @@
       </p:sp>
       <p:sp>
         <p:nvSpPr>
-          <p:cNvPr id="137" name="Shape 134"/>
+          <p:cNvPr id="147" name="Shape 144"/>
           <p:cNvSpPr/>
           <p:nvPr/>
         </p:nvSpPr>
@@ -5108,7 +5418,7 @@
       </p:sp>
       <p:sp>
         <p:nvSpPr>
-          <p:cNvPr id="138" name="Shape 135"/>
+          <p:cNvPr id="148" name="Shape 145"/>
           <p:cNvSpPr/>
           <p:nvPr/>
         </p:nvSpPr>
@@ -5133,7 +5443,7 @@
       </p:sp>
       <p:sp>
         <p:nvSpPr>
-          <p:cNvPr id="139" name="Text 136"/>
+          <p:cNvPr id="149" name="Text 146"/>
           <p:cNvSpPr txBox="1"/>
           <p:nvPr/>
         </p:nvSpPr>
@@ -5172,7 +5482,7 @@
       </p:sp>
       <p:sp>
         <p:nvSpPr>
-          <p:cNvPr id="140" name="Shape 137"/>
+          <p:cNvPr id="150" name="Shape 147"/>
           <p:cNvSpPr/>
           <p:nvPr/>
         </p:nvSpPr>
@@ -5197,7 +5507,7 @@
       </p:sp>
       <p:sp>
         <p:nvSpPr>
-          <p:cNvPr id="141" name="Shape 138"/>
+          <p:cNvPr id="151" name="Shape 148"/>
           <p:cNvSpPr/>
           <p:nvPr/>
         </p:nvSpPr>
@@ -5222,7 +5532,7 @@
       </p:sp>
       <p:sp>
         <p:nvSpPr>
-          <p:cNvPr id="142" name="Shape 139"/>
+          <p:cNvPr id="152" name="Shape 149"/>
           <p:cNvSpPr/>
           <p:nvPr/>
         </p:nvSpPr>
@@ -5247,7 +5557,7 @@
       </p:sp>
       <p:sp>
         <p:nvSpPr>
-          <p:cNvPr id="143" name="Shape 140"/>
+          <p:cNvPr id="153" name="Shape 150"/>
           <p:cNvSpPr/>
           <p:nvPr/>
         </p:nvSpPr>
@@ -5272,7 +5582,7 @@
       </p:sp>
       <p:sp>
         <p:nvSpPr>
-          <p:cNvPr id="144" name="Shape 141"/>
+          <p:cNvPr id="154" name="Shape 151"/>
           <p:cNvSpPr/>
           <p:nvPr/>
         </p:nvSpPr>
@@ -5297,7 +5607,7 @@
       </p:sp>
       <p:sp>
         <p:nvSpPr>
-          <p:cNvPr id="145" name="Text 142"/>
+          <p:cNvPr id="155" name="Text 152"/>
           <p:cNvSpPr txBox="1"/>
           <p:nvPr/>
         </p:nvSpPr>
@@ -5336,7 +5646,7 @@
       </p:sp>
       <p:sp>
         <p:nvSpPr>
-          <p:cNvPr id="146" name="Shape 143"/>
+          <p:cNvPr id="156" name="Shape 153"/>
           <p:cNvSpPr/>
           <p:nvPr/>
         </p:nvSpPr>
@@ -5363,7 +5673,7 @@
       </p:sp>
       <p:sp>
         <p:nvSpPr>
-          <p:cNvPr id="147" name="Shape 144"/>
+          <p:cNvPr id="157" name="Shape 154"/>
           <p:cNvSpPr/>
           <p:nvPr/>
         </p:nvSpPr>
@@ -5390,7 +5700,7 @@
       </p:sp>
       <p:sp>
         <p:nvSpPr>
-          <p:cNvPr id="148" name="Shape 145"/>
+          <p:cNvPr id="158" name="Shape 155"/>
           <p:cNvSpPr/>
           <p:nvPr/>
         </p:nvSpPr>
@@ -5417,7 +5727,7 @@
       </p:sp>
       <p:sp>
         <p:nvSpPr>
-          <p:cNvPr id="149" name="Shape 146"/>
+          <p:cNvPr id="159" name="Shape 156"/>
           <p:cNvSpPr/>
           <p:nvPr/>
         </p:nvSpPr>
@@ -5442,7 +5752,7 @@
       </p:sp>
       <p:sp>
         <p:nvSpPr>
-          <p:cNvPr id="150" name="Text 147"/>
+          <p:cNvPr id="160" name="Text 157"/>
           <p:cNvSpPr txBox="1"/>
           <p:nvPr/>
         </p:nvSpPr>
@@ -5481,7 +5791,7 @@
       </p:sp>
       <p:sp>
         <p:nvSpPr>
-          <p:cNvPr id="151" name="Text 148"/>
+          <p:cNvPr id="161" name="Text 158"/>
           <p:cNvSpPr txBox="1"/>
           <p:nvPr/>
         </p:nvSpPr>
@@ -5520,7 +5830,7 @@
       </p:sp>
       <p:sp>
         <p:nvSpPr>
-          <p:cNvPr id="152" name="Text 149"/>
+          <p:cNvPr id="162" name="Text 159"/>
           <p:cNvSpPr txBox="1"/>
           <p:nvPr/>
         </p:nvSpPr>
@@ -5559,7 +5869,7 @@
       </p:sp>
       <p:sp>
         <p:nvSpPr>
-          <p:cNvPr id="153" name="Shape 150"/>
+          <p:cNvPr id="163" name="Shape 160"/>
           <p:cNvSpPr/>
           <p:nvPr/>
         </p:nvSpPr>
@@ -5584,7 +5894,7 @@
       </p:sp>
       <p:sp>
         <p:nvSpPr>
-          <p:cNvPr id="154" name="Shape 151"/>
+          <p:cNvPr id="164" name="Shape 161"/>
           <p:cNvSpPr/>
           <p:nvPr/>
         </p:nvSpPr>
@@ -5609,7 +5919,7 @@
       </p:sp>
       <p:sp>
         <p:nvSpPr>
-          <p:cNvPr id="155" name="Shape 152"/>
+          <p:cNvPr id="165" name="Shape 162"/>
           <p:cNvSpPr/>
           <p:nvPr/>
         </p:nvSpPr>
@@ -5634,7 +5944,7 @@
       </p:sp>
       <p:sp>
         <p:nvSpPr>
-          <p:cNvPr id="156" name="Shape 153"/>
+          <p:cNvPr id="166" name="Shape 163"/>
           <p:cNvSpPr/>
           <p:nvPr/>
         </p:nvSpPr>
@@ -5659,7 +5969,7 @@
       </p:sp>
       <p:sp>
         <p:nvSpPr>
-          <p:cNvPr id="157" name="Shape 154"/>
+          <p:cNvPr id="167" name="Shape 164"/>
           <p:cNvSpPr/>
           <p:nvPr/>
         </p:nvSpPr>
@@ -5684,7 +5994,7 @@
       </p:sp>
       <p:sp>
         <p:nvSpPr>
-          <p:cNvPr id="158" name="Text 155"/>
+          <p:cNvPr id="168" name="Text 165"/>
           <p:cNvSpPr txBox="1"/>
           <p:nvPr/>
         </p:nvSpPr>
@@ -5723,7 +6033,7 @@
       </p:sp>
       <p:sp>
         <p:nvSpPr>
-          <p:cNvPr id="159" name="Shape 156"/>
+          <p:cNvPr id="169" name="Shape 166"/>
           <p:cNvSpPr/>
           <p:nvPr/>
         </p:nvSpPr>
@@ -5748,7 +6058,7 @@
       </p:sp>
       <p:sp>
         <p:nvSpPr>
-          <p:cNvPr id="160" name="Shape 157"/>
+          <p:cNvPr id="170" name="Shape 167"/>
           <p:cNvSpPr/>
           <p:nvPr/>
         </p:nvSpPr>
@@ -5773,7 +6083,7 @@
       </p:sp>
       <p:sp>
         <p:nvSpPr>
-          <p:cNvPr id="161" name="Shape 158"/>
+          <p:cNvPr id="171" name="Shape 168"/>
           <p:cNvSpPr/>
           <p:nvPr/>
         </p:nvSpPr>
@@ -5798,7 +6108,7 @@
       </p:sp>
       <p:sp>
         <p:nvSpPr>
-          <p:cNvPr id="162" name="Shape 159"/>
+          <p:cNvPr id="172" name="Shape 169"/>
           <p:cNvSpPr/>
           <p:nvPr/>
         </p:nvSpPr>
@@ -5823,7 +6133,7 @@
       </p:sp>
       <p:sp>
         <p:nvSpPr>
-          <p:cNvPr id="163" name="Shape 160"/>
+          <p:cNvPr id="173" name="Shape 170"/>
           <p:cNvSpPr/>
           <p:nvPr/>
         </p:nvSpPr>
@@ -5848,7 +6158,7 @@
       </p:sp>
       <p:sp>
         <p:nvSpPr>
-          <p:cNvPr id="164" name="Text 161"/>
+          <p:cNvPr id="174" name="Text 171"/>
           <p:cNvSpPr txBox="1"/>
           <p:nvPr/>
         </p:nvSpPr>
@@ -5887,7 +6197,7 @@
       </p:sp>
       <p:sp>
         <p:nvSpPr>
-          <p:cNvPr id="165" name="Shape 162"/>
+          <p:cNvPr id="175" name="Shape 172"/>
           <p:cNvSpPr/>
           <p:nvPr/>
         </p:nvSpPr>
@@ -5912,7 +6222,7 @@
       </p:sp>
       <p:sp>
         <p:nvSpPr>
-          <p:cNvPr id="166" name="Shape 163"/>
+          <p:cNvPr id="176" name="Shape 173"/>
           <p:cNvSpPr/>
           <p:nvPr/>
         </p:nvSpPr>
@@ -5937,7 +6247,7 @@
       </p:sp>
       <p:sp>
         <p:nvSpPr>
-          <p:cNvPr id="167" name="Shape 164"/>
+          <p:cNvPr id="177" name="Shape 174"/>
           <p:cNvSpPr/>
           <p:nvPr/>
         </p:nvSpPr>
@@ -5962,7 +6272,7 @@
       </p:sp>
       <p:sp>
         <p:nvSpPr>
-          <p:cNvPr id="168" name="Shape 165"/>
+          <p:cNvPr id="178" name="Shape 175"/>
           <p:cNvSpPr/>
           <p:nvPr/>
         </p:nvSpPr>
@@ -5987,7 +6297,7 @@
       </p:sp>
       <p:sp>
         <p:nvSpPr>
-          <p:cNvPr id="169" name="Shape 166"/>
+          <p:cNvPr id="179" name="Shape 176"/>
           <p:cNvSpPr/>
           <p:nvPr/>
         </p:nvSpPr>
@@ -6012,7 +6322,7 @@
       </p:sp>
       <p:sp>
         <p:nvSpPr>
-          <p:cNvPr id="170" name="Text 167"/>
+          <p:cNvPr id="180" name="Text 177"/>
           <p:cNvSpPr txBox="1"/>
           <p:nvPr/>
         </p:nvSpPr>
@@ -6051,7 +6361,7 @@
       </p:sp>
       <p:sp>
         <p:nvSpPr>
-          <p:cNvPr id="171" name="Shape 168"/>
+          <p:cNvPr id="181" name="Shape 178"/>
           <p:cNvSpPr/>
           <p:nvPr/>
         </p:nvSpPr>
@@ -6076,7 +6386,7 @@
       </p:sp>
       <p:sp>
         <p:nvSpPr>
-          <p:cNvPr id="172" name="Shape 169"/>
+          <p:cNvPr id="182" name="Shape 179"/>
           <p:cNvSpPr/>
           <p:nvPr/>
         </p:nvSpPr>
@@ -6101,7 +6411,7 @@
       </p:sp>
       <p:sp>
         <p:nvSpPr>
-          <p:cNvPr id="173" name="Shape 170"/>
+          <p:cNvPr id="183" name="Shape 180"/>
           <p:cNvSpPr/>
           <p:nvPr/>
         </p:nvSpPr>
@@ -6126,7 +6436,7 @@
       </p:sp>
       <p:sp>
         <p:nvSpPr>
-          <p:cNvPr id="174" name="Shape 171"/>
+          <p:cNvPr id="184" name="Shape 181"/>
           <p:cNvSpPr/>
           <p:nvPr/>
         </p:nvSpPr>
@@ -6151,7 +6461,7 @@
       </p:sp>
       <p:sp>
         <p:nvSpPr>
-          <p:cNvPr id="175" name="Shape 172"/>
+          <p:cNvPr id="185" name="Shape 182"/>
           <p:cNvSpPr/>
           <p:nvPr/>
         </p:nvSpPr>
@@ -6176,7 +6486,7 @@
       </p:sp>
       <p:sp>
         <p:nvSpPr>
-          <p:cNvPr id="176" name="Text 173"/>
+          <p:cNvPr id="186" name="Text 183"/>
           <p:cNvSpPr txBox="1"/>
           <p:nvPr/>
         </p:nvSpPr>
@@ -6215,7 +6525,7 @@
       </p:sp>
       <p:sp>
         <p:nvSpPr>
-          <p:cNvPr id="177" name="Shape 174"/>
+          <p:cNvPr id="187" name="Shape 184"/>
           <p:cNvSpPr/>
           <p:nvPr/>
         </p:nvSpPr>
@@ -6242,7 +6552,7 @@
       </p:sp>
       <p:sp>
         <p:nvSpPr>
-          <p:cNvPr id="178" name="Shape 175"/>
+          <p:cNvPr id="188" name="Shape 185"/>
           <p:cNvSpPr/>
           <p:nvPr/>
         </p:nvSpPr>
@@ -6269,7 +6579,7 @@
       </p:sp>
       <p:sp>
         <p:nvSpPr>
-          <p:cNvPr id="179" name="Shape 176"/>
+          <p:cNvPr id="189" name="Shape 186"/>
           <p:cNvSpPr/>
           <p:nvPr/>
         </p:nvSpPr>
@@ -6296,7 +6606,7 @@
       </p:sp>
       <p:sp>
         <p:nvSpPr>
-          <p:cNvPr id="180" name="Shape 177"/>
+          <p:cNvPr id="190" name="Shape 187"/>
           <p:cNvSpPr/>
           <p:nvPr/>
         </p:nvSpPr>
@@ -6321,7 +6631,7 @@
       </p:sp>
       <p:sp>
         <p:nvSpPr>
-          <p:cNvPr id="181" name="Text 178"/>
+          <p:cNvPr id="191" name="Text 188"/>
           <p:cNvSpPr txBox="1"/>
           <p:nvPr/>
         </p:nvSpPr>
@@ -6360,7 +6670,7 @@
       </p:sp>
       <p:sp>
         <p:nvSpPr>
-          <p:cNvPr id="182" name="Text 179"/>
+          <p:cNvPr id="192" name="Text 189"/>
           <p:cNvSpPr txBox="1"/>
           <p:nvPr/>
         </p:nvSpPr>
@@ -6399,7 +6709,7 @@
       </p:sp>
       <p:sp>
         <p:nvSpPr>
-          <p:cNvPr id="183" name="Text 180"/>
+          <p:cNvPr id="193" name="Text 190"/>
           <p:cNvSpPr txBox="1"/>
           <p:nvPr/>
         </p:nvSpPr>
@@ -6438,7 +6748,7 @@
       </p:sp>
       <p:sp>
         <p:nvSpPr>
-          <p:cNvPr id="184" name="Shape 181"/>
+          <p:cNvPr id="194" name="Shape 191"/>
           <p:cNvSpPr/>
           <p:nvPr/>
         </p:nvSpPr>
@@ -6463,7 +6773,7 @@
       </p:sp>
       <p:sp>
         <p:nvSpPr>
-          <p:cNvPr id="185" name="Shape 182"/>
+          <p:cNvPr id="195" name="Shape 192"/>
           <p:cNvSpPr/>
           <p:nvPr/>
         </p:nvSpPr>
@@ -6488,7 +6798,7 @@
       </p:sp>
       <p:sp>
         <p:nvSpPr>
-          <p:cNvPr id="186" name="Shape 183"/>
+          <p:cNvPr id="196" name="Shape 193"/>
           <p:cNvSpPr/>
           <p:nvPr/>
         </p:nvSpPr>
@@ -6513,7 +6823,7 @@
       </p:sp>
       <p:sp>
         <p:nvSpPr>
-          <p:cNvPr id="187" name="Shape 184"/>
+          <p:cNvPr id="197" name="Shape 194"/>
           <p:cNvSpPr/>
           <p:nvPr/>
         </p:nvSpPr>
@@ -6538,7 +6848,7 @@
       </p:sp>
       <p:sp>
         <p:nvSpPr>
-          <p:cNvPr id="188" name="Shape 185"/>
+          <p:cNvPr id="198" name="Shape 195"/>
           <p:cNvSpPr/>
           <p:nvPr/>
         </p:nvSpPr>
@@ -6563,7 +6873,7 @@
       </p:sp>
       <p:sp>
         <p:nvSpPr>
-          <p:cNvPr id="189" name="Text 186"/>
+          <p:cNvPr id="199" name="Text 196"/>
           <p:cNvSpPr txBox="1"/>
           <p:nvPr/>
         </p:nvSpPr>
@@ -6602,7 +6912,7 @@
       </p:sp>
       <p:sp>
         <p:nvSpPr>
-          <p:cNvPr id="190" name="Shape 187"/>
+          <p:cNvPr id="200" name="Shape 197"/>
           <p:cNvSpPr/>
           <p:nvPr/>
         </p:nvSpPr>
@@ -6627,7 +6937,7 @@
       </p:sp>
       <p:sp>
         <p:nvSpPr>
-          <p:cNvPr id="191" name="Shape 188"/>
+          <p:cNvPr id="201" name="Shape 198"/>
           <p:cNvSpPr/>
           <p:nvPr/>
         </p:nvSpPr>
@@ -6652,7 +6962,7 @@
       </p:sp>
       <p:sp>
         <p:nvSpPr>
-          <p:cNvPr id="192" name="Shape 189"/>
+          <p:cNvPr id="202" name="Shape 199"/>
           <p:cNvSpPr/>
           <p:nvPr/>
         </p:nvSpPr>
@@ -6677,7 +6987,7 @@
       </p:sp>
       <p:sp>
         <p:nvSpPr>
-          <p:cNvPr id="193" name="Shape 190"/>
+          <p:cNvPr id="203" name="Shape 200"/>
           <p:cNvSpPr/>
           <p:nvPr/>
         </p:nvSpPr>
@@ -6702,7 +7012,7 @@
       </p:sp>
       <p:sp>
         <p:nvSpPr>
-          <p:cNvPr id="194" name="Shape 191"/>
+          <p:cNvPr id="204" name="Shape 201"/>
           <p:cNvSpPr/>
           <p:nvPr/>
         </p:nvSpPr>
@@ -6727,7 +7037,7 @@
       </p:sp>
       <p:sp>
         <p:nvSpPr>
-          <p:cNvPr id="195" name="Text 192"/>
+          <p:cNvPr id="205" name="Text 202"/>
           <p:cNvSpPr txBox="1"/>
           <p:nvPr/>
         </p:nvSpPr>
@@ -6766,7 +7076,7 @@
       </p:sp>
       <p:sp>
         <p:nvSpPr>
-          <p:cNvPr id="196" name="Shape 193"/>
+          <p:cNvPr id="206" name="Shape 203"/>
           <p:cNvSpPr/>
           <p:nvPr/>
         </p:nvSpPr>
@@ -6791,7 +7101,7 @@
       </p:sp>
       <p:sp>
         <p:nvSpPr>
-          <p:cNvPr id="197" name="Shape 194"/>
+          <p:cNvPr id="207" name="Shape 204"/>
           <p:cNvSpPr/>
           <p:nvPr/>
         </p:nvSpPr>
@@ -6816,7 +7126,7 @@
       </p:sp>
       <p:sp>
         <p:nvSpPr>
-          <p:cNvPr id="198" name="Shape 195"/>
+          <p:cNvPr id="208" name="Shape 205"/>
           <p:cNvSpPr/>
           <p:nvPr/>
         </p:nvSpPr>
@@ -6841,7 +7151,7 @@
       </p:sp>
       <p:sp>
         <p:nvSpPr>
-          <p:cNvPr id="199" name="Shape 196"/>
+          <p:cNvPr id="209" name="Shape 206"/>
           <p:cNvSpPr/>
           <p:nvPr/>
         </p:nvSpPr>
@@ -6866,7 +7176,7 @@
       </p:sp>
       <p:sp>
         <p:nvSpPr>
-          <p:cNvPr id="200" name="Shape 197"/>
+          <p:cNvPr id="210" name="Shape 207"/>
           <p:cNvSpPr/>
           <p:nvPr/>
         </p:nvSpPr>
@@ -6891,7 +7201,7 @@
       </p:sp>
       <p:sp>
         <p:nvSpPr>
-          <p:cNvPr id="201" name="Text 198"/>
+          <p:cNvPr id="211" name="Text 208"/>
           <p:cNvSpPr txBox="1"/>
           <p:nvPr/>
         </p:nvSpPr>
@@ -6930,7 +7240,7 @@
       </p:sp>
       <p:sp>
         <p:nvSpPr>
-          <p:cNvPr id="202" name="Shape 199"/>
+          <p:cNvPr id="212" name="Shape 209"/>
           <p:cNvSpPr/>
           <p:nvPr/>
         </p:nvSpPr>
@@ -6955,7 +7265,7 @@
       </p:sp>
       <p:sp>
         <p:nvSpPr>
-          <p:cNvPr id="203" name="Shape 200"/>
+          <p:cNvPr id="213" name="Shape 210"/>
           <p:cNvSpPr/>
           <p:nvPr/>
         </p:nvSpPr>
@@ -6980,7 +7290,7 @@
       </p:sp>
       <p:sp>
         <p:nvSpPr>
-          <p:cNvPr id="204" name="Shape 201"/>
+          <p:cNvPr id="214" name="Shape 211"/>
           <p:cNvSpPr/>
           <p:nvPr/>
         </p:nvSpPr>
@@ -7005,7 +7315,7 @@
       </p:sp>
       <p:sp>
         <p:nvSpPr>
-          <p:cNvPr id="205" name="Shape 202"/>
+          <p:cNvPr id="215" name="Shape 212"/>
           <p:cNvSpPr/>
           <p:nvPr/>
         </p:nvSpPr>
@@ -7030,7 +7340,7 @@
       </p:sp>
       <p:sp>
         <p:nvSpPr>
-          <p:cNvPr id="206" name="Shape 203"/>
+          <p:cNvPr id="216" name="Shape 213"/>
           <p:cNvSpPr/>
           <p:nvPr/>
         </p:nvSpPr>
@@ -7055,7 +7365,7 @@
       </p:sp>
       <p:sp>
         <p:nvSpPr>
-          <p:cNvPr id="207" name="Text 204"/>
+          <p:cNvPr id="217" name="Text 214"/>
           <p:cNvSpPr txBox="1"/>
           <p:nvPr/>
         </p:nvSpPr>
@@ -7094,7 +7404,7 @@
       </p:sp>
       <p:sp>
         <p:nvSpPr>
-          <p:cNvPr id="208" name="Shape 205"/>
+          <p:cNvPr id="218" name="Shape 215"/>
           <p:cNvSpPr/>
           <p:nvPr/>
         </p:nvSpPr>
@@ -7121,7 +7431,7 @@
       </p:sp>
       <p:sp>
         <p:nvSpPr>
-          <p:cNvPr id="209" name="Shape 206"/>
+          <p:cNvPr id="219" name="Shape 216"/>
           <p:cNvSpPr/>
           <p:nvPr/>
         </p:nvSpPr>
@@ -7148,7 +7458,7 @@
       </p:sp>
       <p:sp>
         <p:nvSpPr>
-          <p:cNvPr id="210" name="Shape 207"/>
+          <p:cNvPr id="220" name="Shape 217"/>
           <p:cNvSpPr/>
           <p:nvPr/>
         </p:nvSpPr>
@@ -7175,7 +7485,7 @@
       </p:sp>
       <p:sp>
         <p:nvSpPr>
-          <p:cNvPr id="211" name="Shape 208"/>
+          <p:cNvPr id="221" name="Shape 218"/>
           <p:cNvSpPr/>
           <p:nvPr/>
         </p:nvSpPr>
@@ -7200,7 +7510,7 @@
       </p:sp>
       <p:sp>
         <p:nvSpPr>
-          <p:cNvPr id="212" name="Text 209"/>
+          <p:cNvPr id="222" name="Text 219"/>
           <p:cNvSpPr txBox="1"/>
           <p:nvPr/>
         </p:nvSpPr>
@@ -7239,7 +7549,7 @@
       </p:sp>
       <p:sp>
         <p:nvSpPr>
-          <p:cNvPr id="213" name="Text 210"/>
+          <p:cNvPr id="223" name="Text 220"/>
           <p:cNvSpPr txBox="1"/>
           <p:nvPr/>
         </p:nvSpPr>
@@ -7278,7 +7588,7 @@
       </p:sp>
       <p:sp>
         <p:nvSpPr>
-          <p:cNvPr id="214" name="Text 211"/>
+          <p:cNvPr id="224" name="Text 221"/>
           <p:cNvSpPr txBox="1"/>
           <p:nvPr/>
         </p:nvSpPr>
@@ -7317,7 +7627,7 @@
       </p:sp>
       <p:sp>
         <p:nvSpPr>
-          <p:cNvPr id="215" name="Shape 212"/>
+          <p:cNvPr id="225" name="Shape 222"/>
           <p:cNvSpPr/>
           <p:nvPr/>
         </p:nvSpPr>
@@ -7342,7 +7652,7 @@
       </p:sp>
       <p:sp>
         <p:nvSpPr>
-          <p:cNvPr id="216" name="Shape 213"/>
+          <p:cNvPr id="226" name="Shape 223"/>
           <p:cNvSpPr/>
           <p:nvPr/>
         </p:nvSpPr>
@@ -7367,7 +7677,7 @@
       </p:sp>
       <p:sp>
         <p:nvSpPr>
-          <p:cNvPr id="217" name="Shape 214"/>
+          <p:cNvPr id="227" name="Shape 224"/>
           <p:cNvSpPr/>
           <p:nvPr/>
         </p:nvSpPr>
@@ -7392,7 +7702,7 @@
       </p:sp>
       <p:sp>
         <p:nvSpPr>
-          <p:cNvPr id="218" name="Shape 215"/>
+          <p:cNvPr id="228" name="Shape 225"/>
           <p:cNvSpPr/>
           <p:nvPr/>
         </p:nvSpPr>
@@ -7417,7 +7727,7 @@
       </p:sp>
       <p:sp>
         <p:nvSpPr>
-          <p:cNvPr id="219" name="Shape 216"/>
+          <p:cNvPr id="229" name="Shape 226"/>
           <p:cNvSpPr/>
           <p:nvPr/>
         </p:nvSpPr>
@@ -7442,7 +7752,7 @@
       </p:sp>
       <p:sp>
         <p:nvSpPr>
-          <p:cNvPr id="220" name="Text 217"/>
+          <p:cNvPr id="230" name="Text 227"/>
           <p:cNvSpPr txBox="1"/>
           <p:nvPr/>
         </p:nvSpPr>
@@ -7481,7 +7791,7 @@
       </p:sp>
       <p:sp>
         <p:nvSpPr>
-          <p:cNvPr id="221" name="Shape 218"/>
+          <p:cNvPr id="231" name="Shape 228"/>
           <p:cNvSpPr/>
           <p:nvPr/>
         </p:nvSpPr>
@@ -7506,7 +7816,7 @@
       </p:sp>
       <p:sp>
         <p:nvSpPr>
-          <p:cNvPr id="222" name="Shape 219"/>
+          <p:cNvPr id="232" name="Shape 229"/>
           <p:cNvSpPr/>
           <p:nvPr/>
         </p:nvSpPr>
@@ -7531,7 +7841,7 @@
       </p:sp>
       <p:sp>
         <p:nvSpPr>
-          <p:cNvPr id="223" name="Shape 220"/>
+          <p:cNvPr id="233" name="Shape 230"/>
           <p:cNvSpPr/>
           <p:nvPr/>
         </p:nvSpPr>
@@ -7556,7 +7866,7 @@
       </p:sp>
       <p:sp>
         <p:nvSpPr>
-          <p:cNvPr id="224" name="Shape 221"/>
+          <p:cNvPr id="234" name="Shape 231"/>
           <p:cNvSpPr/>
           <p:nvPr/>
         </p:nvSpPr>
@@ -7581,7 +7891,7 @@
       </p:sp>
       <p:sp>
         <p:nvSpPr>
-          <p:cNvPr id="225" name="Shape 222"/>
+          <p:cNvPr id="235" name="Shape 232"/>
           <p:cNvSpPr/>
           <p:nvPr/>
         </p:nvSpPr>
@@ -7606,7 +7916,7 @@
       </p:sp>
       <p:sp>
         <p:nvSpPr>
-          <p:cNvPr id="226" name="Text 223"/>
+          <p:cNvPr id="236" name="Text 233"/>
           <p:cNvSpPr txBox="1"/>
           <p:nvPr/>
         </p:nvSpPr>
@@ -7645,7 +7955,7 @@
       </p:sp>
       <p:sp>
         <p:nvSpPr>
-          <p:cNvPr id="227" name="Shape 224"/>
+          <p:cNvPr id="237" name="Shape 234"/>
           <p:cNvSpPr/>
           <p:nvPr/>
         </p:nvSpPr>
@@ -7670,7 +7980,7 @@
       </p:sp>
       <p:sp>
         <p:nvSpPr>
-          <p:cNvPr id="228" name="Shape 225"/>
+          <p:cNvPr id="238" name="Shape 235"/>
           <p:cNvSpPr/>
           <p:nvPr/>
         </p:nvSpPr>
@@ -7695,7 +8005,7 @@
       </p:sp>
       <p:sp>
         <p:nvSpPr>
-          <p:cNvPr id="229" name="Shape 226"/>
+          <p:cNvPr id="239" name="Shape 236"/>
           <p:cNvSpPr/>
           <p:nvPr/>
         </p:nvSpPr>
@@ -7720,7 +8030,7 @@
       </p:sp>
       <p:sp>
         <p:nvSpPr>
-          <p:cNvPr id="230" name="Shape 227"/>
+          <p:cNvPr id="240" name="Shape 237"/>
           <p:cNvSpPr/>
           <p:nvPr/>
         </p:nvSpPr>
@@ -7745,7 +8055,7 @@
       </p:sp>
       <p:sp>
         <p:nvSpPr>
-          <p:cNvPr id="231" name="Shape 228"/>
+          <p:cNvPr id="241" name="Shape 238"/>
           <p:cNvSpPr/>
           <p:nvPr/>
         </p:nvSpPr>
@@ -7770,7 +8080,7 @@
       </p:sp>
       <p:sp>
         <p:nvSpPr>
-          <p:cNvPr id="232" name="Text 229"/>
+          <p:cNvPr id="242" name="Text 239"/>
           <p:cNvSpPr txBox="1"/>
           <p:nvPr/>
         </p:nvSpPr>
@@ -7809,7 +8119,7 @@
       </p:sp>
       <p:sp>
         <p:nvSpPr>
-          <p:cNvPr id="233" name="Shape 230"/>
+          <p:cNvPr id="243" name="Shape 240"/>
           <p:cNvSpPr/>
           <p:nvPr/>
         </p:nvSpPr>
@@ -7834,7 +8144,7 @@
       </p:sp>
       <p:sp>
         <p:nvSpPr>
-          <p:cNvPr id="234" name="Shape 231"/>
+          <p:cNvPr id="244" name="Shape 241"/>
           <p:cNvSpPr/>
           <p:nvPr/>
         </p:nvSpPr>
@@ -7859,7 +8169,7 @@
       </p:sp>
       <p:sp>
         <p:nvSpPr>
-          <p:cNvPr id="235" name="Shape 232"/>
+          <p:cNvPr id="245" name="Shape 242"/>
           <p:cNvSpPr/>
           <p:nvPr/>
         </p:nvSpPr>
@@ -7884,7 +8194,7 @@
       </p:sp>
       <p:sp>
         <p:nvSpPr>
-          <p:cNvPr id="236" name="Shape 233"/>
+          <p:cNvPr id="246" name="Shape 243"/>
           <p:cNvSpPr/>
           <p:nvPr/>
         </p:nvSpPr>
@@ -7909,7 +8219,7 @@
       </p:sp>
       <p:sp>
         <p:nvSpPr>
-          <p:cNvPr id="237" name="Shape 234"/>
+          <p:cNvPr id="247" name="Shape 244"/>
           <p:cNvSpPr/>
           <p:nvPr/>
         </p:nvSpPr>
@@ -7934,7 +8244,7 @@
       </p:sp>
       <p:sp>
         <p:nvSpPr>
-          <p:cNvPr id="238" name="Text 235"/>
+          <p:cNvPr id="248" name="Text 245"/>
           <p:cNvSpPr txBox="1"/>
           <p:nvPr/>
         </p:nvSpPr>
@@ -7973,7 +8283,7 @@
       </p:sp>
       <p:sp>
         <p:nvSpPr>
-          <p:cNvPr id="239" name="Shape 236"/>
+          <p:cNvPr id="249" name="Shape 246"/>
           <p:cNvSpPr/>
           <p:nvPr/>
         </p:nvSpPr>
@@ -8000,7 +8310,7 @@
       </p:sp>
       <p:sp>
         <p:nvSpPr>
-          <p:cNvPr id="240" name="Shape 237"/>
+          <p:cNvPr id="250" name="Shape 247"/>
           <p:cNvSpPr/>
           <p:nvPr/>
         </p:nvSpPr>
@@ -8027,7 +8337,7 @@
       </p:sp>
       <p:sp>
         <p:nvSpPr>
-          <p:cNvPr id="241" name="Shape 238"/>
+          <p:cNvPr id="251" name="Shape 248"/>
           <p:cNvSpPr/>
           <p:nvPr/>
         </p:nvSpPr>
@@ -8054,7 +8364,7 @@
       </p:sp>
       <p:sp>
         <p:nvSpPr>
-          <p:cNvPr id="242" name="Shape 239"/>
+          <p:cNvPr id="252" name="Shape 249"/>
           <p:cNvSpPr/>
           <p:nvPr/>
         </p:nvSpPr>
@@ -8079,7 +8389,7 @@
       </p:sp>
       <p:sp>
         <p:nvSpPr>
-          <p:cNvPr id="243" name="Text 240"/>
+          <p:cNvPr id="253" name="Text 250"/>
           <p:cNvSpPr txBox="1"/>
           <p:nvPr/>
         </p:nvSpPr>
@@ -8118,7 +8428,7 @@
       </p:sp>
       <p:sp>
         <p:nvSpPr>
-          <p:cNvPr id="244" name="Text 241"/>
+          <p:cNvPr id="254" name="Text 251"/>
           <p:cNvSpPr txBox="1"/>
           <p:nvPr/>
         </p:nvSpPr>
@@ -8157,7 +8467,7 @@
       </p:sp>
       <p:sp>
         <p:nvSpPr>
-          <p:cNvPr id="245" name="Text 242"/>
+          <p:cNvPr id="255" name="Text 252"/>
           <p:cNvSpPr txBox="1"/>
           <p:nvPr/>
         </p:nvSpPr>
@@ -8196,7 +8506,7 @@
       </p:sp>
       <p:sp>
         <p:nvSpPr>
-          <p:cNvPr id="246" name="Shape 243"/>
+          <p:cNvPr id="256" name="Shape 253"/>
           <p:cNvSpPr/>
           <p:nvPr/>
         </p:nvSpPr>
@@ -8221,7 +8531,7 @@
       </p:sp>
       <p:sp>
         <p:nvSpPr>
-          <p:cNvPr id="247" name="Shape 244"/>
+          <p:cNvPr id="257" name="Shape 254"/>
           <p:cNvSpPr/>
           <p:nvPr/>
         </p:nvSpPr>
@@ -8246,7 +8556,7 @@
       </p:sp>
       <p:sp>
         <p:nvSpPr>
-          <p:cNvPr id="248" name="Shape 245"/>
+          <p:cNvPr id="258" name="Shape 255"/>
           <p:cNvSpPr/>
           <p:nvPr/>
         </p:nvSpPr>
@@ -8271,7 +8581,7 @@
       </p:sp>
       <p:sp>
         <p:nvSpPr>
-          <p:cNvPr id="249" name="Shape 246"/>
+          <p:cNvPr id="259" name="Shape 256"/>
           <p:cNvSpPr/>
           <p:nvPr/>
         </p:nvSpPr>
@@ -8296,7 +8606,7 @@
       </p:sp>
       <p:sp>
         <p:nvSpPr>
-          <p:cNvPr id="250" name="Shape 247"/>
+          <p:cNvPr id="260" name="Shape 257"/>
           <p:cNvSpPr/>
           <p:nvPr/>
         </p:nvSpPr>
@@ -8321,7 +8631,7 @@
       </p:sp>
       <p:sp>
         <p:nvSpPr>
-          <p:cNvPr id="251" name="Text 248"/>
+          <p:cNvPr id="261" name="Text 258"/>
           <p:cNvSpPr txBox="1"/>
           <p:nvPr/>
         </p:nvSpPr>
@@ -8360,7 +8670,7 @@
       </p:sp>
       <p:sp>
         <p:nvSpPr>
-          <p:cNvPr id="252" name="Shape 249"/>
+          <p:cNvPr id="262" name="Shape 259"/>
           <p:cNvSpPr/>
           <p:nvPr/>
         </p:nvSpPr>
@@ -8385,7 +8695,7 @@
       </p:sp>
       <p:sp>
         <p:nvSpPr>
-          <p:cNvPr id="253" name="Shape 250"/>
+          <p:cNvPr id="263" name="Shape 260"/>
           <p:cNvSpPr/>
           <p:nvPr/>
         </p:nvSpPr>
@@ -8410,7 +8720,7 @@
       </p:sp>
       <p:sp>
         <p:nvSpPr>
-          <p:cNvPr id="254" name="Shape 251"/>
+          <p:cNvPr id="264" name="Shape 261"/>
           <p:cNvSpPr/>
           <p:nvPr/>
         </p:nvSpPr>
@@ -8435,7 +8745,7 @@
       </p:sp>
       <p:sp>
         <p:nvSpPr>
-          <p:cNvPr id="255" name="Shape 252"/>
+          <p:cNvPr id="265" name="Shape 262"/>
           <p:cNvSpPr/>
           <p:nvPr/>
         </p:nvSpPr>
@@ -8460,7 +8770,7 @@
       </p:sp>
       <p:sp>
         <p:nvSpPr>
-          <p:cNvPr id="256" name="Shape 253"/>
+          <p:cNvPr id="266" name="Shape 263"/>
           <p:cNvSpPr/>
           <p:nvPr/>
         </p:nvSpPr>
@@ -8485,7 +8795,7 @@
       </p:sp>
       <p:sp>
         <p:nvSpPr>
-          <p:cNvPr id="257" name="Text 254"/>
+          <p:cNvPr id="267" name="Text 264"/>
           <p:cNvSpPr txBox="1"/>
           <p:nvPr/>
         </p:nvSpPr>
@@ -8524,7 +8834,7 @@
       </p:sp>
       <p:sp>
         <p:nvSpPr>
-          <p:cNvPr id="258" name="Shape 255"/>
+          <p:cNvPr id="268" name="Shape 265"/>
           <p:cNvSpPr/>
           <p:nvPr/>
         </p:nvSpPr>
@@ -8549,7 +8859,7 @@
       </p:sp>
       <p:sp>
         <p:nvSpPr>
-          <p:cNvPr id="259" name="Shape 256"/>
+          <p:cNvPr id="269" name="Shape 266"/>
           <p:cNvSpPr/>
           <p:nvPr/>
         </p:nvSpPr>
@@ -8574,7 +8884,7 @@
       </p:sp>
       <p:sp>
         <p:nvSpPr>
-          <p:cNvPr id="260" name="Shape 257"/>
+          <p:cNvPr id="270" name="Shape 267"/>
           <p:cNvSpPr/>
           <p:nvPr/>
         </p:nvSpPr>
@@ -8599,7 +8909,7 @@
       </p:sp>
       <p:sp>
         <p:nvSpPr>
-          <p:cNvPr id="261" name="Shape 258"/>
+          <p:cNvPr id="271" name="Shape 268"/>
           <p:cNvSpPr/>
           <p:nvPr/>
         </p:nvSpPr>
@@ -8624,7 +8934,7 @@
       </p:sp>
       <p:sp>
         <p:nvSpPr>
-          <p:cNvPr id="262" name="Shape 259"/>
+          <p:cNvPr id="272" name="Shape 269"/>
           <p:cNvSpPr/>
           <p:nvPr/>
         </p:nvSpPr>
@@ -8649,7 +8959,7 @@
       </p:sp>
       <p:sp>
         <p:nvSpPr>
-          <p:cNvPr id="263" name="Text 260"/>
+          <p:cNvPr id="273" name="Text 270"/>
           <p:cNvSpPr txBox="1"/>
           <p:nvPr/>
         </p:nvSpPr>
@@ -8688,7 +8998,7 @@
       </p:sp>
       <p:sp>
         <p:nvSpPr>
-          <p:cNvPr id="264" name="Shape 261"/>
+          <p:cNvPr id="274" name="Shape 271"/>
           <p:cNvSpPr/>
           <p:nvPr/>
         </p:nvSpPr>
@@ -8713,7 +9023,7 @@
       </p:sp>
       <p:sp>
         <p:nvSpPr>
-          <p:cNvPr id="265" name="Shape 262"/>
+          <p:cNvPr id="275" name="Shape 272"/>
           <p:cNvSpPr/>
           <p:nvPr/>
         </p:nvSpPr>
@@ -8738,7 +9048,7 @@
       </p:sp>
       <p:sp>
         <p:nvSpPr>
-          <p:cNvPr id="266" name="Shape 263"/>
+          <p:cNvPr id="276" name="Shape 273"/>
           <p:cNvSpPr/>
           <p:nvPr/>
         </p:nvSpPr>
@@ -8763,7 +9073,7 @@
       </p:sp>
       <p:sp>
         <p:nvSpPr>
-          <p:cNvPr id="267" name="Shape 264"/>
+          <p:cNvPr id="277" name="Shape 274"/>
           <p:cNvSpPr/>
           <p:nvPr/>
         </p:nvSpPr>
@@ -8788,7 +9098,7 @@
       </p:sp>
       <p:sp>
         <p:nvSpPr>
-          <p:cNvPr id="268" name="Shape 265"/>
+          <p:cNvPr id="278" name="Shape 275"/>
           <p:cNvSpPr/>
           <p:nvPr/>
         </p:nvSpPr>
@@ -8813,7 +9123,7 @@
       </p:sp>
       <p:sp>
         <p:nvSpPr>
-          <p:cNvPr id="269" name="Text 266"/>
+          <p:cNvPr id="279" name="Text 276"/>
           <p:cNvSpPr txBox="1"/>
           <p:nvPr/>
         </p:nvSpPr>
@@ -8852,7 +9162,7 @@
       </p:sp>
       <p:sp>
         <p:nvSpPr>
-          <p:cNvPr id="270" name="Shape 267"/>
+          <p:cNvPr id="280" name="Shape 277"/>
           <p:cNvSpPr/>
           <p:nvPr/>
         </p:nvSpPr>
@@ -8879,7 +9189,7 @@
       </p:sp>
       <p:sp>
         <p:nvSpPr>
-          <p:cNvPr id="271" name="Shape 268"/>
+          <p:cNvPr id="281" name="Shape 278"/>
           <p:cNvSpPr/>
           <p:nvPr/>
         </p:nvSpPr>
@@ -8906,7 +9216,7 @@
       </p:sp>
       <p:sp>
         <p:nvSpPr>
-          <p:cNvPr id="272" name="Shape 269"/>
+          <p:cNvPr id="282" name="Shape 279"/>
           <p:cNvSpPr/>
           <p:nvPr/>
         </p:nvSpPr>
@@ -8933,7 +9243,7 @@
       </p:sp>
       <p:sp>
         <p:nvSpPr>
-          <p:cNvPr id="273" name="Shape 270"/>
+          <p:cNvPr id="283" name="Shape 280"/>
           <p:cNvSpPr/>
           <p:nvPr/>
         </p:nvSpPr>
@@ -8958,7 +9268,7 @@
       </p:sp>
       <p:sp>
         <p:nvSpPr>
-          <p:cNvPr id="274" name="Text 271"/>
+          <p:cNvPr id="284" name="Text 281"/>
           <p:cNvSpPr txBox="1"/>
           <p:nvPr/>
         </p:nvSpPr>
@@ -8997,7 +9307,7 @@
       </p:sp>
       <p:sp>
         <p:nvSpPr>
-          <p:cNvPr id="275" name="Text 272"/>
+          <p:cNvPr id="285" name="Text 282"/>
           <p:cNvSpPr txBox="1"/>
           <p:nvPr/>
         </p:nvSpPr>
@@ -9036,7 +9346,7 @@
       </p:sp>
       <p:sp>
         <p:nvSpPr>
-          <p:cNvPr id="276" name="Text 273"/>
+          <p:cNvPr id="286" name="Text 283"/>
           <p:cNvSpPr txBox="1"/>
           <p:nvPr/>
         </p:nvSpPr>
@@ -9075,7 +9385,7 @@
       </p:sp>
       <p:sp>
         <p:nvSpPr>
-          <p:cNvPr id="277" name="Shape 274"/>
+          <p:cNvPr id="287" name="Shape 284"/>
           <p:cNvSpPr/>
           <p:nvPr/>
         </p:nvSpPr>
@@ -9100,7 +9410,7 @@
       </p:sp>
       <p:sp>
         <p:nvSpPr>
-          <p:cNvPr id="278" name="Shape 275"/>
+          <p:cNvPr id="288" name="Shape 285"/>
           <p:cNvSpPr/>
           <p:nvPr/>
         </p:nvSpPr>
@@ -9125,7 +9435,7 @@
       </p:sp>
       <p:sp>
         <p:nvSpPr>
-          <p:cNvPr id="279" name="Shape 276"/>
+          <p:cNvPr id="289" name="Shape 286"/>
           <p:cNvSpPr/>
           <p:nvPr/>
         </p:nvSpPr>
@@ -9150,7 +9460,7 @@
       </p:sp>
       <p:sp>
         <p:nvSpPr>
-          <p:cNvPr id="280" name="Shape 277"/>
+          <p:cNvPr id="290" name="Shape 287"/>
           <p:cNvSpPr/>
           <p:nvPr/>
         </p:nvSpPr>
@@ -9175,7 +9485,7 @@
       </p:sp>
       <p:sp>
         <p:nvSpPr>
-          <p:cNvPr id="281" name="Shape 278"/>
+          <p:cNvPr id="291" name="Shape 288"/>
           <p:cNvSpPr/>
           <p:nvPr/>
         </p:nvSpPr>
@@ -9200,7 +9510,7 @@
       </p:sp>
       <p:sp>
         <p:nvSpPr>
-          <p:cNvPr id="282" name="Text 279"/>
+          <p:cNvPr id="292" name="Text 289"/>
           <p:cNvSpPr txBox="1"/>
           <p:nvPr/>
         </p:nvSpPr>
@@ -9239,7 +9549,7 @@
       </p:sp>
       <p:sp>
         <p:nvSpPr>
-          <p:cNvPr id="283" name="Shape 280"/>
+          <p:cNvPr id="293" name="Shape 290"/>
           <p:cNvSpPr/>
           <p:nvPr/>
         </p:nvSpPr>
@@ -9264,7 +9574,7 @@
       </p:sp>
       <p:sp>
         <p:nvSpPr>
-          <p:cNvPr id="284" name="Shape 281"/>
+          <p:cNvPr id="294" name="Shape 291"/>
           <p:cNvSpPr/>
           <p:nvPr/>
         </p:nvSpPr>
@@ -9289,7 +9599,7 @@
       </p:sp>
       <p:sp>
         <p:nvSpPr>
-          <p:cNvPr id="285" name="Shape 282"/>
+          <p:cNvPr id="295" name="Shape 292"/>
           <p:cNvSpPr/>
           <p:nvPr/>
         </p:nvSpPr>
@@ -9314,7 +9624,7 @@
       </p:sp>
       <p:sp>
         <p:nvSpPr>
-          <p:cNvPr id="286" name="Shape 283"/>
+          <p:cNvPr id="296" name="Shape 293"/>
           <p:cNvSpPr/>
           <p:nvPr/>
         </p:nvSpPr>
@@ -9339,7 +9649,7 @@
       </p:sp>
       <p:sp>
         <p:nvSpPr>
-          <p:cNvPr id="287" name="Shape 284"/>
+          <p:cNvPr id="297" name="Shape 294"/>
           <p:cNvSpPr/>
           <p:nvPr/>
         </p:nvSpPr>
@@ -9364,7 +9674,7 @@
       </p:sp>
       <p:sp>
         <p:nvSpPr>
-          <p:cNvPr id="288" name="Text 285"/>
+          <p:cNvPr id="298" name="Text 295"/>
           <p:cNvSpPr txBox="1"/>
           <p:nvPr/>
         </p:nvSpPr>
@@ -9403,7 +9713,7 @@
       </p:sp>
       <p:sp>
         <p:nvSpPr>
-          <p:cNvPr id="289" name="Shape 286"/>
+          <p:cNvPr id="299" name="Shape 296"/>
           <p:cNvSpPr/>
           <p:nvPr/>
         </p:nvSpPr>
@@ -9428,7 +9738,7 @@
       </p:sp>
       <p:sp>
         <p:nvSpPr>
-          <p:cNvPr id="290" name="Shape 287"/>
+          <p:cNvPr id="300" name="Shape 297"/>
           <p:cNvSpPr/>
           <p:nvPr/>
         </p:nvSpPr>
@@ -9453,7 +9763,7 @@
       </p:sp>
       <p:sp>
         <p:nvSpPr>
-          <p:cNvPr id="291" name="Shape 288"/>
+          <p:cNvPr id="301" name="Shape 298"/>
           <p:cNvSpPr/>
           <p:nvPr/>
         </p:nvSpPr>
@@ -9478,7 +9788,7 @@
       </p:sp>
       <p:sp>
         <p:nvSpPr>
-          <p:cNvPr id="292" name="Shape 289"/>
+          <p:cNvPr id="302" name="Shape 299"/>
           <p:cNvSpPr/>
           <p:nvPr/>
         </p:nvSpPr>
@@ -9503,7 +9813,7 @@
       </p:sp>
       <p:sp>
         <p:nvSpPr>
-          <p:cNvPr id="293" name="Shape 290"/>
+          <p:cNvPr id="303" name="Shape 300"/>
           <p:cNvSpPr/>
           <p:nvPr/>
         </p:nvSpPr>
@@ -9528,7 +9838,7 @@
       </p:sp>
       <p:sp>
         <p:nvSpPr>
-          <p:cNvPr id="294" name="Text 291"/>
+          <p:cNvPr id="304" name="Text 301"/>
           <p:cNvSpPr txBox="1"/>
           <p:nvPr/>
         </p:nvSpPr>
@@ -9567,7 +9877,7 @@
       </p:sp>
       <p:sp>
         <p:nvSpPr>
-          <p:cNvPr id="295" name="Shape 292"/>
+          <p:cNvPr id="305" name="Shape 302"/>
           <p:cNvSpPr/>
           <p:nvPr/>
         </p:nvSpPr>
@@ -9592,7 +9902,7 @@
       </p:sp>
       <p:sp>
         <p:nvSpPr>
-          <p:cNvPr id="296" name="Shape 293"/>
+          <p:cNvPr id="306" name="Shape 303"/>
           <p:cNvSpPr/>
           <p:nvPr/>
         </p:nvSpPr>
@@ -9617,7 +9927,7 @@
       </p:sp>
       <p:sp>
         <p:nvSpPr>
-          <p:cNvPr id="297" name="Shape 294"/>
+          <p:cNvPr id="307" name="Shape 304"/>
           <p:cNvSpPr/>
           <p:nvPr/>
         </p:nvSpPr>
@@ -9642,7 +9952,7 @@
       </p:sp>
       <p:sp>
         <p:nvSpPr>
-          <p:cNvPr id="298" name="Shape 295"/>
+          <p:cNvPr id="308" name="Shape 305"/>
           <p:cNvSpPr/>
           <p:nvPr/>
         </p:nvSpPr>
@@ -9667,7 +9977,7 @@
       </p:sp>
       <p:sp>
         <p:nvSpPr>
-          <p:cNvPr id="299" name="Shape 296"/>
+          <p:cNvPr id="309" name="Shape 306"/>
           <p:cNvSpPr/>
           <p:nvPr/>
         </p:nvSpPr>
@@ -9692,7 +10002,7 @@
       </p:sp>
       <p:sp>
         <p:nvSpPr>
-          <p:cNvPr id="300" name="Text 297"/>
+          <p:cNvPr id="310" name="Text 307"/>
           <p:cNvSpPr txBox="1"/>
           <p:nvPr/>
         </p:nvSpPr>
@@ -9731,7 +10041,7 @@
       </p:sp>
       <p:sp>
         <p:nvSpPr>
-          <p:cNvPr id="301" name="Shape 298"/>
+          <p:cNvPr id="311" name="Shape 308"/>
           <p:cNvSpPr/>
           <p:nvPr/>
         </p:nvSpPr>
@@ -9758,7 +10068,7 @@
       </p:sp>
       <p:sp>
         <p:nvSpPr>
-          <p:cNvPr id="302" name="Shape 299"/>
+          <p:cNvPr id="312" name="Shape 309"/>
           <p:cNvSpPr/>
           <p:nvPr/>
         </p:nvSpPr>
@@ -9785,7 +10095,7 @@
       </p:sp>
       <p:sp>
         <p:nvSpPr>
-          <p:cNvPr id="303" name="Shape 300"/>
+          <p:cNvPr id="313" name="Shape 310"/>
           <p:cNvSpPr/>
           <p:nvPr/>
         </p:nvSpPr>
@@ -9812,7 +10122,7 @@
       </p:sp>
       <p:sp>
         <p:nvSpPr>
-          <p:cNvPr id="304" name="Shape 301"/>
+          <p:cNvPr id="314" name="Shape 311"/>
           <p:cNvSpPr/>
           <p:nvPr/>
         </p:nvSpPr>
@@ -9837,7 +10147,7 @@
       </p:sp>
       <p:sp>
         <p:nvSpPr>
-          <p:cNvPr id="305" name="Text 302"/>
+          <p:cNvPr id="315" name="Text 312"/>
           <p:cNvSpPr txBox="1"/>
           <p:nvPr/>
         </p:nvSpPr>
@@ -9865,7 +10175,7 @@
       </p:sp>
       <p:sp>
         <p:nvSpPr>
-          <p:cNvPr id="306" name="Text 303"/>
+          <p:cNvPr id="316" name="Text 313"/>
           <p:cNvSpPr txBox="1"/>
           <p:nvPr/>
         </p:nvSpPr>
@@ -9904,7 +10214,7 @@
       </p:sp>
       <p:sp>
         <p:nvSpPr>
-          <p:cNvPr id="307" name="Text 304"/>
+          <p:cNvPr id="317" name="Text 314"/>
           <p:cNvSpPr txBox="1"/>
           <p:nvPr/>
         </p:nvSpPr>
@@ -9943,7 +10253,7 @@
       </p:sp>
       <p:sp>
         <p:nvSpPr>
-          <p:cNvPr id="308" name="Text 305"/>
+          <p:cNvPr id="318" name="Text 315"/>
           <p:cNvSpPr txBox="1"/>
           <p:nvPr/>
         </p:nvSpPr>
@@ -9982,7 +10292,7 @@
       </p:sp>
       <p:sp>
         <p:nvSpPr>
-          <p:cNvPr id="309" name="Shape 306"/>
+          <p:cNvPr id="319" name="Shape 316"/>
           <p:cNvSpPr/>
           <p:nvPr/>
         </p:nvSpPr>
@@ -10007,7 +10317,7 @@
       </p:sp>
       <p:sp>
         <p:nvSpPr>
-          <p:cNvPr id="310" name="Shape 307"/>
+          <p:cNvPr id="320" name="Shape 317"/>
           <p:cNvSpPr/>
           <p:nvPr/>
         </p:nvSpPr>
@@ -10032,7 +10342,7 @@
       </p:sp>
       <p:sp>
         <p:nvSpPr>
-          <p:cNvPr id="311" name="Shape 308"/>
+          <p:cNvPr id="321" name="Shape 318"/>
           <p:cNvSpPr/>
           <p:nvPr/>
         </p:nvSpPr>
@@ -10057,7 +10367,7 @@
       </p:sp>
       <p:sp>
         <p:nvSpPr>
-          <p:cNvPr id="312" name="Shape 309"/>
+          <p:cNvPr id="322" name="Shape 319"/>
           <p:cNvSpPr/>
           <p:nvPr/>
         </p:nvSpPr>
@@ -10082,7 +10392,7 @@
       </p:sp>
       <p:sp>
         <p:nvSpPr>
-          <p:cNvPr id="313" name="Shape 310"/>
+          <p:cNvPr id="323" name="Shape 320"/>
           <p:cNvSpPr/>
           <p:nvPr/>
         </p:nvSpPr>
@@ -10107,7 +10417,7 @@
       </p:sp>
       <p:sp>
         <p:nvSpPr>
-          <p:cNvPr id="314" name="Text 311"/>
+          <p:cNvPr id="324" name="Text 321"/>
           <p:cNvSpPr txBox="1"/>
           <p:nvPr/>
         </p:nvSpPr>
@@ -10146,7 +10456,7 @@
       </p:sp>
       <p:sp>
         <p:nvSpPr>
-          <p:cNvPr id="315" name="Shape 312"/>
+          <p:cNvPr id="325" name="Shape 322"/>
           <p:cNvSpPr/>
           <p:nvPr/>
         </p:nvSpPr>
@@ -10171,7 +10481,7 @@
       </p:sp>
       <p:sp>
         <p:nvSpPr>
-          <p:cNvPr id="316" name="Shape 313"/>
+          <p:cNvPr id="326" name="Shape 323"/>
           <p:cNvSpPr/>
           <p:nvPr/>
         </p:nvSpPr>
@@ -10196,7 +10506,7 @@
       </p:sp>
       <p:sp>
         <p:nvSpPr>
-          <p:cNvPr id="317" name="Shape 314"/>
+          <p:cNvPr id="327" name="Shape 324"/>
           <p:cNvSpPr/>
           <p:nvPr/>
         </p:nvSpPr>
@@ -10221,7 +10531,7 @@
       </p:sp>
       <p:sp>
         <p:nvSpPr>
-          <p:cNvPr id="318" name="Shape 315"/>
+          <p:cNvPr id="328" name="Shape 325"/>
           <p:cNvSpPr/>
           <p:nvPr/>
         </p:nvSpPr>
@@ -10246,7 +10556,7 @@
       </p:sp>
       <p:sp>
         <p:nvSpPr>
-          <p:cNvPr id="319" name="Shape 316"/>
+          <p:cNvPr id="329" name="Shape 326"/>
           <p:cNvSpPr/>
           <p:nvPr/>
         </p:nvSpPr>
@@ -10271,7 +10581,7 @@
       </p:sp>
       <p:sp>
         <p:nvSpPr>
-          <p:cNvPr id="320" name="Text 317"/>
+          <p:cNvPr id="330" name="Text 327"/>
           <p:cNvSpPr txBox="1"/>
           <p:nvPr/>
         </p:nvSpPr>
@@ -10310,7 +10620,7 @@
       </p:sp>
       <p:sp>
         <p:nvSpPr>
-          <p:cNvPr id="321" name="Shape 318"/>
+          <p:cNvPr id="331" name="Shape 328"/>
           <p:cNvSpPr/>
           <p:nvPr/>
         </p:nvSpPr>
@@ -10335,7 +10645,7 @@
       </p:sp>
       <p:sp>
         <p:nvSpPr>
-          <p:cNvPr id="322" name="Shape 319"/>
+          <p:cNvPr id="332" name="Shape 329"/>
           <p:cNvSpPr/>
           <p:nvPr/>
         </p:nvSpPr>
@@ -10360,7 +10670,7 @@
       </p:sp>
       <p:sp>
         <p:nvSpPr>
-          <p:cNvPr id="323" name="Shape 320"/>
+          <p:cNvPr id="333" name="Shape 330"/>
           <p:cNvSpPr/>
           <p:nvPr/>
         </p:nvSpPr>
@@ -10385,7 +10695,7 @@
       </p:sp>
       <p:sp>
         <p:nvSpPr>
-          <p:cNvPr id="324" name="Shape 321"/>
+          <p:cNvPr id="334" name="Shape 331"/>
           <p:cNvSpPr/>
           <p:nvPr/>
         </p:nvSpPr>
@@ -10410,7 +10720,7 @@
       </p:sp>
       <p:sp>
         <p:nvSpPr>
-          <p:cNvPr id="325" name="Shape 322"/>
+          <p:cNvPr id="335" name="Shape 332"/>
           <p:cNvSpPr/>
           <p:nvPr/>
         </p:nvSpPr>
@@ -10435,7 +10745,7 @@
       </p:sp>
       <p:sp>
         <p:nvSpPr>
-          <p:cNvPr id="326" name="Text 323"/>
+          <p:cNvPr id="336" name="Text 333"/>
           <p:cNvSpPr txBox="1"/>
           <p:nvPr/>
         </p:nvSpPr>
@@ -10474,7 +10784,7 @@
       </p:sp>
       <p:sp>
         <p:nvSpPr>
-          <p:cNvPr id="327" name="Shape 324"/>
+          <p:cNvPr id="337" name="Shape 334"/>
           <p:cNvSpPr/>
           <p:nvPr/>
         </p:nvSpPr>
@@ -10499,7 +10809,7 @@
       </p:sp>
       <p:sp>
         <p:nvSpPr>
-          <p:cNvPr id="328" name="Shape 325"/>
+          <p:cNvPr id="338" name="Shape 335"/>
           <p:cNvSpPr/>
           <p:nvPr/>
         </p:nvSpPr>
@@ -10524,7 +10834,7 @@
       </p:sp>
       <p:sp>
         <p:nvSpPr>
-          <p:cNvPr id="329" name="Shape 326"/>
+          <p:cNvPr id="339" name="Shape 336"/>
           <p:cNvSpPr/>
           <p:nvPr/>
         </p:nvSpPr>
@@ -10549,7 +10859,7 @@
       </p:sp>
       <p:sp>
         <p:nvSpPr>
-          <p:cNvPr id="330" name="Shape 327"/>
+          <p:cNvPr id="340" name="Shape 337"/>
           <p:cNvSpPr/>
           <p:nvPr/>
         </p:nvSpPr>
@@ -10574,7 +10884,7 @@
       </p:sp>
       <p:sp>
         <p:nvSpPr>
-          <p:cNvPr id="331" name="Shape 328"/>
+          <p:cNvPr id="341" name="Shape 338"/>
           <p:cNvSpPr/>
           <p:nvPr/>
         </p:nvSpPr>
@@ -10599,7 +10909,7 @@
       </p:sp>
       <p:sp>
         <p:nvSpPr>
-          <p:cNvPr id="332" name="Text 329"/>
+          <p:cNvPr id="342" name="Text 339"/>
           <p:cNvSpPr txBox="1"/>
           <p:nvPr/>
         </p:nvSpPr>
@@ -10638,7 +10948,7 @@
       </p:sp>
       <p:sp>
         <p:nvSpPr>
-          <p:cNvPr id="333" name="Shape 330"/>
+          <p:cNvPr id="343" name="Shape 340"/>
           <p:cNvSpPr/>
           <p:nvPr/>
         </p:nvSpPr>
@@ -10665,7 +10975,7 @@
       </p:sp>
       <p:sp>
         <p:nvSpPr>
-          <p:cNvPr id="334" name="Shape 331"/>
+          <p:cNvPr id="344" name="Shape 341"/>
           <p:cNvSpPr/>
           <p:nvPr/>
         </p:nvSpPr>
@@ -10692,7 +11002,7 @@
       </p:sp>
       <p:sp>
         <p:nvSpPr>
-          <p:cNvPr id="335" name="Text 332"/>
+          <p:cNvPr id="345" name="Text 342"/>
           <p:cNvSpPr txBox="1"/>
           <p:nvPr/>
         </p:nvSpPr>
@@ -10726,7 +11036,7 @@
                 <a:ea typeface="Geist Medium" pitchFamily="34" charset="-122"/>
                 <a:cs typeface="Geist Medium" pitchFamily="34" charset="-120"/>
               </a:rPr>
-              <a:t>1  Adviser legal  </a:t>
+              <a:t>1  AI may advise  </a:t>
             </a:r>
             <a:pPr indent="0" marL="0">
               <a:spcAft>
@@ -11436,7 +11746,7 @@
                 <a:ea typeface="Geist Medium" pitchFamily="34" charset="-122"/>
                 <a:cs typeface="Geist Medium" pitchFamily="34" charset="-120"/>
               </a:rPr>
-              <a:t>4  Trigger freshness  </a:t>
+              <a:t>4  New regulation enforcement  </a:t>
             </a:r>
             <a:pPr indent="0" marL="0">
               <a:spcAft>

</xml_diff>